<commit_message>
v5: emergency escalation when local path dead/slow, sequential server start with retries, soft-deadline escalation of unanswered tasks, strict no-swap CI
Co-Authored-By: Claude Fable 5 <noreply@anthropic.com>
Claude-Session: https://claude.ai/code/session_01PbXJjcaafj5pB2RxXcLkh6
</commit_message>
<xml_diff>
--- a/media/FrugalRouter-deck.pptx
+++ b/media/FrugalRouter-deck.pptx
@@ -4,6 +4,9 @@
   <p:sldMasterIdLst>
     <p:sldMasterId id="2147483648" r:id="rId1"/>
   </p:sldMasterIdLst>
+  <p:notesMasterIdLst>
+    <p:notesMasterId r:id="rId9"/>
+  </p:notesMasterIdLst>
   <p:sldIdLst>
     <p:sldId id="256" r:id="rId2"/>
     <p:sldId id="257" r:id="rId3"/>
@@ -13,9 +16,6 @@
     <p:sldId id="261" r:id="rId7"/>
     <p:sldId id="262" r:id="rId8"/>
   </p:sldIdLst>
-  <p:notesMasterIdLst>
-    <p:notesMasterId r:id="rId9"/>
-  </p:notesMasterIdLst>
   <p:sldSz cx="12192000" cy="6858000"/>
   <p:notesSz cx="6858000" cy="12192000"/>
   <p:defaultTextStyle>
@@ -110,6 +110,11 @@
       </a:defRPr>
     </a:lvl9pPr>
   </p:defaultTextStyle>
+  <p:extLst>
+    <p:ext uri="{EFAFB233-063F-42B5-8137-9DF3F51BA10A}">
+      <p15:sldGuideLst xmlns:p15="http://schemas.microsoft.com/office/powerpoint/2012/main"/>
+    </p:ext>
+  </p:extLst>
 </p:presentation>
 </file>
 
@@ -135,234 +140,10 @@
           <a:chExt cx="0" cy="0"/>
         </a:xfrm>
       </p:grpSpPr>
-      <p:sp>
-        <p:nvSpPr>
-          <p:cNvPr id="2" name="Header Placeholder 1"/>
-          <p:cNvSpPr>
-            <a:spLocks noGrp="1"/>
-          </p:cNvSpPr>
-          <p:nvPr>
-            <p:ph type="hdr" sz="quarter"/>
-          </p:nvPr>
-        </p:nvSpPr>
-        <p:spPr>
-          <a:xfrm>
-            <a:off x="0" y="0"/>
-            <a:ext cx="2971800" cy="458788"/>
-          </a:xfrm>
-          <a:prstGeom prst="rect">
-            <a:avLst/>
-          </a:prstGeom>
-        </p:spPr>
-        <p:txBody>
-          <a:bodyPr vert="horz" lIns="91440" tIns="45720" rIns="91440" bIns="45720" rtlCol="0"/>
-          <a:lstStyle>
-            <a:lvl1pPr algn="l">
-              <a:defRPr sz="1200"/>
-            </a:lvl1pPr>
-          </a:lstStyle>
-          <a:p>
-            <a:endParaRPr lang="en-US"/>
-          </a:p>
-        </p:txBody>
-      </p:sp>
-      <p:sp>
-        <p:nvSpPr>
-          <p:cNvPr id="3" name="Date Placeholder 2"/>
-          <p:cNvSpPr>
-            <a:spLocks noGrp="1"/>
-          </p:cNvSpPr>
-          <p:nvPr>
-            <p:ph type="dt" idx="1"/>
-          </p:nvPr>
-        </p:nvSpPr>
-        <p:spPr>
-          <a:xfrm>
-            <a:off x="3884613" y="0"/>
-            <a:ext cx="2971800" cy="458788"/>
-          </a:xfrm>
-          <a:prstGeom prst="rect">
-            <a:avLst/>
-          </a:prstGeom>
-        </p:spPr>
-        <p:txBody>
-          <a:bodyPr vert="horz" lIns="91440" tIns="45720" rIns="91440" bIns="45720" rtlCol="0"/>
-          <a:lstStyle>
-            <a:lvl1pPr algn="r">
-              <a:defRPr sz="1200"/>
-            </a:lvl1pPr>
-          </a:lstStyle>
-          <a:p>
-            <a:fld id="{5282F153-3F37-0F45-9E97-73ACFA13230C}" type="datetimeFigureOut">
-              <a:rPr lang="en-US"/>
-              <a:t>7/23/19</a:t>
-            </a:fld>
-            <a:endParaRPr lang="en-US"/>
-          </a:p>
-        </p:txBody>
-      </p:sp>
-      <p:sp>
-        <p:nvSpPr>
-          <p:cNvPr id="4" name="Slide Image Placeholder 3"/>
-          <p:cNvSpPr>
-            <a:spLocks noGrp="1" noRot="1" noChangeAspect="1"/>
-          </p:cNvSpPr>
-          <p:nvPr>
-            <p:ph type="sldImg" idx="2"/>
-          </p:nvPr>
-        </p:nvSpPr>
-        <p:spPr>
-          <a:xfrm>
-            <a:off x="685800" y="1143000"/>
-            <a:ext cx="5486400" cy="3086100"/>
-          </a:xfrm>
-          <a:prstGeom prst="rect">
-            <a:avLst/>
-          </a:prstGeom>
-          <a:noFill/>
-          <a:ln w="12700">
-            <a:solidFill>
-              <a:prstClr val="black"/>
-            </a:solidFill>
-          </a:ln>
-        </p:spPr>
-        <p:txBody>
-          <a:bodyPr vert="horz" lIns="91440" tIns="45720" rIns="91440" bIns="45720" rtlCol="0" anchor="ctr"/>
-          <a:lstStyle/>
-          <a:p>
-            <a:endParaRPr lang="en-US"/>
-          </a:p>
-        </p:txBody>
-      </p:sp>
-      <p:sp>
-        <p:nvSpPr>
-          <p:cNvPr id="5" name="Notes Placeholder 4"/>
-          <p:cNvSpPr>
-            <a:spLocks noGrp="1"/>
-          </p:cNvSpPr>
-          <p:nvPr>
-            <p:ph type="body" sz="quarter" idx="3"/>
-          </p:nvPr>
-        </p:nvSpPr>
-        <p:spPr>
-          <a:xfrm>
-            <a:off x="685800" y="4400550"/>
-            <a:ext cx="5486400" cy="3600450"/>
-          </a:xfrm>
-          <a:prstGeom prst="rect">
-            <a:avLst/>
-          </a:prstGeom>
-        </p:spPr>
-        <p:txBody>
-          <a:bodyPr vert="horz" lIns="91440" tIns="45720" rIns="91440" bIns="45720" rtlCol="0"/>
-          <a:lstStyle/>
-          <a:p>
-            <a:pPr lvl="0"/>
-            <a:r>
-              <a:rPr lang="en-US"/>
-              <a:t>Click to edit Master text styles</a:t>
-            </a:r>
-          </a:p>
-          <a:p>
-            <a:pPr lvl="1"/>
-            <a:r>
-              <a:rPr lang="en-US"/>
-              <a:t>Second level</a:t>
-            </a:r>
-          </a:p>
-          <a:p>
-            <a:pPr lvl="2"/>
-            <a:r>
-              <a:rPr lang="en-US"/>
-              <a:t>Third level</a:t>
-            </a:r>
-          </a:p>
-          <a:p>
-            <a:pPr lvl="3"/>
-            <a:r>
-              <a:rPr lang="en-US"/>
-              <a:t>Fourth level</a:t>
-            </a:r>
-          </a:p>
-          <a:p>
-            <a:pPr lvl="4"/>
-            <a:r>
-              <a:rPr lang="en-US"/>
-              <a:t>Fifth level</a:t>
-            </a:r>
-          </a:p>
-        </p:txBody>
-      </p:sp>
-      <p:sp>
-        <p:nvSpPr>
-          <p:cNvPr id="6" name="Footer Placeholder 5"/>
-          <p:cNvSpPr>
-            <a:spLocks noGrp="1"/>
-          </p:cNvSpPr>
-          <p:nvPr>
-            <p:ph type="ftr" sz="quarter" idx="4"/>
-          </p:nvPr>
-        </p:nvSpPr>
-        <p:spPr>
-          <a:xfrm>
-            <a:off x="0" y="8685213"/>
-            <a:ext cx="2971800" cy="458787"/>
-          </a:xfrm>
-          <a:prstGeom prst="rect">
-            <a:avLst/>
-          </a:prstGeom>
-        </p:spPr>
-        <p:txBody>
-          <a:bodyPr vert="horz" lIns="91440" tIns="45720" rIns="91440" bIns="45720" rtlCol="0" anchor="b"/>
-          <a:lstStyle>
-            <a:lvl1pPr algn="l">
-              <a:defRPr sz="1200"/>
-            </a:lvl1pPr>
-          </a:lstStyle>
-          <a:p>
-            <a:endParaRPr lang="en-US"/>
-          </a:p>
-        </p:txBody>
-      </p:sp>
-      <p:sp>
-        <p:nvSpPr>
-          <p:cNvPr id="7" name="Slide Number Placeholder 6"/>
-          <p:cNvSpPr>
-            <a:spLocks noGrp="1"/>
-          </p:cNvSpPr>
-          <p:nvPr>
-            <p:ph type="sldNum" sz="quarter" idx="5"/>
-          </p:nvPr>
-        </p:nvSpPr>
-        <p:spPr>
-          <a:xfrm>
-            <a:off x="3884613" y="8685213"/>
-            <a:ext cx="2971800" cy="458787"/>
-          </a:xfrm>
-          <a:prstGeom prst="rect">
-            <a:avLst/>
-          </a:prstGeom>
-        </p:spPr>
-        <p:txBody>
-          <a:bodyPr vert="horz" lIns="91440" tIns="45720" rIns="91440" bIns="45720" rtlCol="0" anchor="b"/>
-          <a:lstStyle>
-            <a:lvl1pPr algn="r">
-              <a:defRPr sz="1200"/>
-            </a:lvl1pPr>
-          </a:lstStyle>
-          <a:p>
-            <a:fld id="{CE5E9CC1-C706-0F49-92D6-E571CC5EEA8F}" type="slidenum">
-              <a:rPr lang="en-US"/>
-              <a:t>‹#›</a:t>
-            </a:fld>
-            <a:endParaRPr lang="en-US"/>
-          </a:p>
-        </p:txBody>
-      </p:sp>
     </p:spTree>
     <p:extLst>
       <p:ext uri="{BB962C8B-B14F-4D97-AF65-F5344CB8AC3E}">
-        <p14:creationId xmlns:p14="http://schemas.microsoft.com/office/powerpoint/2010/main" val="1024086991"/>
+        <p14:creationId xmlns:p14="http://schemas.microsoft.com/office/powerpoint/2010/main" val="1910607701"/>
       </p:ext>
     </p:extLst>
   </p:cSld>
@@ -510,7 +291,6 @@
               <a:rPr lang="en-US" dirty="0"/>
               <a:t>This is FrugalRouter, our entry for Track 1 — the hybrid token-efficient routing agent.</a:t>
             </a:r>
-            <a:endParaRPr lang="en-US" dirty="0"/>
           </a:p>
         </p:txBody>
       </p:sp>
@@ -598,7 +378,6 @@
               <a:rPr lang="en-US" dirty="0"/>
               <a:t>Track 1 scores accuracy per Fireworks token — on a 2 vCPU, 4 GB box, with a hard 10-minute limit and no GPU.</a:t>
             </a:r>
-            <a:endParaRPr lang="en-US" dirty="0"/>
           </a:p>
         </p:txBody>
       </p:sp>
@@ -686,7 +465,6 @@
               <a:rPr lang="en-US" dirty="0"/>
               <a:t>Most routers try to pick the cheapest cloud model for each task. We inverted the problem: we make cloud calls unnecessary. Two small quantized models run entirely inside the grading container on two CPU cores — so most answers cost exactly zero tokens.</a:t>
             </a:r>
-            <a:endParaRPr lang="en-US" dirty="0"/>
           </a:p>
         </p:txBody>
       </p:sp>
@@ -774,7 +552,6 @@
               <a:rPr lang="en-US" dirty="0"/>
               <a:t>Small models can’t be trusted raw, so nothing ships unverified. Math answers come from Python programs we actually execute. Generated code only passes when two independent implementations agree on real observed behavior. Logic puzzles are solved by brute-forcing every possibility and proving the answer is unique.</a:t>
             </a:r>
-            <a:endParaRPr lang="en-US" dirty="0"/>
           </a:p>
         </p:txBody>
       </p:sp>
@@ -862,7 +639,6 @@
               <a:rPr lang="en-US" dirty="0"/>
               <a:t>Every answer carries a confidence score. Only the weakest escalate to Fireworks — cheapest first, capped by a hard 900-token budget. We measured every serverless model and picked gpt-oss-120b at low reasoning effort: about 137 tokens for a full word problem.</a:t>
             </a:r>
-            <a:endParaRPr lang="en-US" dirty="0"/>
           </a:p>
         </p:txBody>
       </p:sp>
@@ -950,7 +726,6 @@
               <a:rPr lang="en-US" dirty="0"/>
               <a:t>Everything is engineered so the container cannot time out: a throughput probe sets the speed governor, output is written atomically after every task, and the watchdog guarantees a clean exit before the harness limit. All 19 tasks finish in 232 seconds at grading constraints.</a:t>
             </a:r>
-            <a:endParaRPr lang="en-US" dirty="0"/>
           </a:p>
         </p:txBody>
       </p:sp>
@@ -1038,7 +813,6 @@
               <a:rPr lang="en-US" dirty="0"/>
               <a:t>The result: ninety percent accuracy with zero external tokens, ninety-five with escalation, nineteen tasks in under four minutes on the grading hardware. FrugalRouter — verified answers, almost free.</a:t>
             </a:r>
-            <a:endParaRPr lang="en-US" dirty="0"/>
           </a:p>
         </p:txBody>
       </p:sp>
@@ -1111,6 +885,11 @@
 <file path=ppt/slideMasters/slideMaster1.xml><?xml version="1.0" encoding="utf-8"?>
 <p:sldMaster xmlns:a="http://schemas.openxmlformats.org/drawingml/2006/main" xmlns:r="http://schemas.openxmlformats.org/officeDocument/2006/relationships" xmlns:p="http://schemas.openxmlformats.org/presentationml/2006/main">
   <p:cSld>
+    <p:bg>
+      <p:bgRef idx="1001">
+        <a:schemeClr val="bg1"/>
+      </p:bgRef>
+    </p:bg>
     <p:spTree>
       <p:nvGrpSpPr>
         <p:cNvPr id="1" name=""/>
@@ -1393,6 +1172,7 @@
         <a:solidFill>
           <a:srgbClr val="FFFFFF"/>
         </a:solidFill>
+        <a:effectLst/>
       </p:bgPr>
     </p:bg>
     <p:spTree>
@@ -1430,11 +1210,11 @@
           <a:bodyPr wrap="square" lIns="0" tIns="0" rIns="0" bIns="0" rtlCol="0" anchor="ctr"/>
           <a:lstStyle/>
           <a:p>
-            <a:pPr indent="0" marL="0">
-              <a:buNone/>
-            </a:pPr>
-            <a:r>
-              <a:rPr lang="en-US" sz="1300" b="1" spc="300" kern="0" dirty="0">
+            <a:pPr marL="0" indent="0">
+              <a:buNone/>
+            </a:pPr>
+            <a:r>
+              <a:rPr lang="en-US" sz="1300" b="1" kern="0" spc="300" dirty="0">
                 <a:solidFill>
                   <a:srgbClr val="ED1C24"/>
                 </a:solidFill>
@@ -1469,7 +1249,7 @@
           <a:bodyPr wrap="square" lIns="0" tIns="0" rIns="0" bIns="0" rtlCol="0" anchor="ctr"/>
           <a:lstStyle/>
           <a:p>
-            <a:pPr indent="0" marL="0">
+            <a:pPr marL="0" indent="0">
               <a:buNone/>
             </a:pPr>
             <a:r>
@@ -1508,7 +1288,7 @@
           <a:bodyPr wrap="square" lIns="0" tIns="0" rIns="0" bIns="0" rtlCol="0" anchor="ctr"/>
           <a:lstStyle/>
           <a:p>
-            <a:pPr indent="0" marL="0">
+            <a:pPr marL="0" indent="0">
               <a:lnSpc>
                 <a:spcPct val="115000"/>
               </a:lnSpc>
@@ -1550,7 +1330,7 @@
           <a:bodyPr wrap="square" lIns="0" tIns="0" rIns="0" bIns="0" rtlCol="0" anchor="ctr"/>
           <a:lstStyle/>
           <a:p>
-            <a:pPr indent="0" marL="0">
+            <a:pPr marL="0" indent="0">
               <a:buNone/>
             </a:pPr>
             <a:r>
@@ -1564,9 +1344,6 @@
               </a:rPr>
               <a:t>Local-first inference</a:t>
             </a:r>
-            <a:pPr indent="0" marL="0">
-              <a:buNone/>
-            </a:pPr>
             <a:r>
               <a:rPr lang="en-US" sz="1450" dirty="0">
                 <a:solidFill>
@@ -1578,9 +1355,6 @@
               </a:rPr>
               <a:t>  ·  </a:t>
             </a:r>
-            <a:pPr indent="0" marL="0">
-              <a:buNone/>
-            </a:pPr>
             <a:r>
               <a:rPr lang="en-US" sz="1450" b="1" dirty="0">
                 <a:solidFill>
@@ -1592,9 +1366,6 @@
               </a:rPr>
               <a:t>deterministic verification</a:t>
             </a:r>
-            <a:pPr indent="0" marL="0">
-              <a:buNone/>
-            </a:pPr>
             <a:r>
               <a:rPr lang="en-US" sz="1450" dirty="0">
                 <a:solidFill>
@@ -1606,9 +1377,6 @@
               </a:rPr>
               <a:t>  ·  </a:t>
             </a:r>
-            <a:pPr indent="0" marL="0">
-              <a:buNone/>
-            </a:pPr>
             <a:r>
               <a:rPr lang="en-US" sz="1450" b="1" dirty="0">
                 <a:solidFill>
@@ -1667,7 +1435,7 @@
           <a:bodyPr wrap="square" lIns="0" tIns="0" rIns="0" bIns="0" rtlCol="0" anchor="ctr"/>
           <a:lstStyle/>
           <a:p>
-            <a:pPr algn="ctr" indent="0" marL="0">
+            <a:pPr marL="0" indent="0" algn="ctr">
               <a:buNone/>
             </a:pPr>
             <a:r>
@@ -1679,7 +1447,7 @@
                 <a:ea typeface="Courier New" pitchFamily="34" charset="-122"/>
                 <a:cs typeface="Courier New" pitchFamily="34" charset="-120"/>
               </a:rPr>
-              <a:t>ghcr.io/manan-tech/frugalrouter:v1</a:t>
+              <a:t>ghcr.io/manan-tech/frugalrouter:v3</a:t>
             </a:r>
             <a:endParaRPr lang="en-US" sz="1100" dirty="0"/>
           </a:p>
@@ -1728,7 +1496,7 @@
           <a:bodyPr wrap="square" lIns="0" tIns="0" rIns="0" bIns="0" rtlCol="0" anchor="ctr"/>
           <a:lstStyle/>
           <a:p>
-            <a:pPr algn="ctr" indent="0" marL="0">
+            <a:pPr marL="0" indent="0" algn="ctr">
               <a:buNone/>
             </a:pPr>
             <a:r>
@@ -3242,7 +3010,7 @@
           <a:bodyPr wrap="square" lIns="0" tIns="0" rIns="0" bIns="0" rtlCol="0" anchor="ctr"/>
           <a:lstStyle/>
           <a:p>
-            <a:pPr algn="ctr" indent="0" marL="0">
+            <a:pPr marL="0" indent="0" algn="ctr">
               <a:buNone/>
             </a:pPr>
             <a:r>
@@ -3276,6 +3044,7 @@
         <a:solidFill>
           <a:srgbClr val="FFFFFF"/>
         </a:solidFill>
+        <a:effectLst/>
       </p:bgPr>
     </p:bg>
     <p:spTree>
@@ -3313,7 +3082,7 @@
           <a:bodyPr wrap="square" lIns="0" tIns="0" rIns="0" bIns="0" rtlCol="0" anchor="ctr"/>
           <a:lstStyle/>
           <a:p>
-            <a:pPr indent="0" marL="0">
+            <a:pPr marL="0" indent="0">
               <a:buNone/>
             </a:pPr>
             <a:r>
@@ -3353,257 +3122,7 @@
       </p:sp>
       <p:pic>
         <p:nvPicPr>
-          <p:cNvPr id="4" name="Image 0" descr="preencoded.png">    </p:cNvPr>
-          <p:cNvPicPr>
-            <a:picLocks noChangeAspect="1"/>
-          </p:cNvPicPr>
-          <p:nvPr/>
-        </p:nvPicPr>
-        <p:blipFill>
-          <a:blip r:embed="rId1"/>
-          <a:stretch>
-            <a:fillRect/>
-          </a:stretch>
-        </p:blipFill>
-        <p:spPr>
-          <a:xfrm>
-            <a:off x="950244" y="1700052"/>
-            <a:ext cx="275783" cy="275783"/>
-          </a:xfrm>
-          <a:prstGeom prst="rect">
-            <a:avLst/>
-          </a:prstGeom>
-        </p:spPr>
-      </p:pic>
-      <p:sp>
-        <p:nvSpPr>
-          <p:cNvPr id="5" name="Text 2"/>
-          <p:cNvSpPr/>
-          <p:nvPr/>
-        </p:nvSpPr>
-        <p:spPr>
-          <a:xfrm>
-            <a:off x="1600200" y="1554480"/>
-            <a:ext cx="5212080" cy="292608"/>
-          </a:xfrm>
-          <a:prstGeom prst="rect">
-            <a:avLst/>
-          </a:prstGeom>
-          <a:noFill/>
-          <a:ln/>
-        </p:spPr>
-        <p:txBody>
-          <a:bodyPr wrap="square" lIns="0" tIns="0" rIns="0" bIns="0" rtlCol="0" anchor="ctr"/>
-          <a:lstStyle/>
-          <a:p>
-            <a:pPr indent="0" marL="0">
-              <a:buNone/>
-            </a:pPr>
-            <a:r>
-              <a:rPr lang="en-US" sz="1650" b="1" dirty="0">
-                <a:solidFill>
-                  <a:srgbClr val="26282C"/>
-                </a:solidFill>
-                <a:latin typeface="Arial" pitchFamily="34" charset="0"/>
-                <a:ea typeface="Arial" pitchFamily="34" charset="-122"/>
-                <a:cs typeface="Arial" pitchFamily="34" charset="-120"/>
-              </a:rPr>
-              <a:t>AI spend control — without a quality tax</a:t>
-            </a:r>
-            <a:endParaRPr lang="en-US" sz="1650" dirty="0"/>
-          </a:p>
-        </p:txBody>
-      </p:sp>
-      <p:sp>
-        <p:nvSpPr>
-          <p:cNvPr id="6" name="Text 3"/>
-          <p:cNvSpPr/>
-          <p:nvPr/>
-        </p:nvSpPr>
-        <p:spPr>
-          <a:xfrm>
-            <a:off x="1600200" y="1883664"/>
-            <a:ext cx="5212080" cy="777240"/>
-          </a:xfrm>
-          <a:prstGeom prst="rect">
-            <a:avLst/>
-          </a:prstGeom>
-          <a:noFill/>
-          <a:ln/>
-        </p:spPr>
-        <p:txBody>
-          <a:bodyPr wrap="square" lIns="0" tIns="0" rIns="0" bIns="0" rtlCol="0" anchor="t"/>
-          <a:lstStyle/>
-          <a:p>
-            <a:pPr indent="0" marL="0">
-              <a:lnSpc>
-                <a:spcPct val="112000"/>
-              </a:lnSpc>
-              <a:buNone/>
-            </a:pPr>
-            <a:r>
-              <a:rPr lang="en-US" sz="1300" dirty="0">
-                <a:solidFill>
-                  <a:srgbClr val="63686E"/>
-                </a:solidFill>
-                <a:latin typeface="Arial" pitchFamily="34" charset="0"/>
-                <a:ea typeface="Arial" pitchFamily="34" charset="-122"/>
-                <a:cs typeface="Arial" pitchFamily="34" charset="-120"/>
-              </a:rPr>
-              <a:t>Enterprises want to cut LLM inference cost, but every saved token is worthless if accuracy drops below the bar.</a:t>
-            </a:r>
-            <a:endParaRPr lang="en-US" sz="1300" dirty="0"/>
-          </a:p>
-        </p:txBody>
-      </p:sp>
-      <p:sp>
-        <p:nvSpPr>
-          <p:cNvPr id="7" name="Shape 4"/>
-          <p:cNvSpPr/>
-          <p:nvPr/>
-        </p:nvSpPr>
-        <p:spPr>
-          <a:xfrm>
-            <a:off x="822960" y="2944368"/>
-            <a:ext cx="530352" cy="530352"/>
-          </a:xfrm>
-          <a:prstGeom prst="ellipse">
-            <a:avLst/>
-          </a:prstGeom>
-          <a:solidFill>
-            <a:srgbClr val="FDEBEC"/>
-          </a:solidFill>
-          <a:ln/>
-        </p:spPr>
-      </p:sp>
-      <p:pic>
-        <p:nvPicPr>
-          <p:cNvPr id="8" name="Image 1" descr="preencoded.png">    </p:cNvPr>
-          <p:cNvPicPr>
-            <a:picLocks noChangeAspect="1"/>
-          </p:cNvPicPr>
-          <p:nvPr/>
-        </p:nvPicPr>
-        <p:blipFill>
-          <a:blip r:embed="rId2"/>
-          <a:stretch>
-            <a:fillRect/>
-          </a:stretch>
-        </p:blipFill>
-        <p:spPr>
-          <a:xfrm>
-            <a:off x="950244" y="3071652"/>
-            <a:ext cx="275783" cy="275783"/>
-          </a:xfrm>
-          <a:prstGeom prst="rect">
-            <a:avLst/>
-          </a:prstGeom>
-        </p:spPr>
-      </p:pic>
-      <p:sp>
-        <p:nvSpPr>
-          <p:cNvPr id="9" name="Text 5"/>
-          <p:cNvSpPr/>
-          <p:nvPr/>
-        </p:nvSpPr>
-        <p:spPr>
-          <a:xfrm>
-            <a:off x="1600200" y="2926080"/>
-            <a:ext cx="5212080" cy="292608"/>
-          </a:xfrm>
-          <a:prstGeom prst="rect">
-            <a:avLst/>
-          </a:prstGeom>
-          <a:noFill/>
-          <a:ln/>
-        </p:spPr>
-        <p:txBody>
-          <a:bodyPr wrap="square" lIns="0" tIns="0" rIns="0" bIns="0" rtlCol="0" anchor="ctr"/>
-          <a:lstStyle/>
-          <a:p>
-            <a:pPr indent="0" marL="0">
-              <a:buNone/>
-            </a:pPr>
-            <a:r>
-              <a:rPr lang="en-US" sz="1650" b="1" dirty="0">
-                <a:solidFill>
-                  <a:srgbClr val="26282C"/>
-                </a:solidFill>
-                <a:latin typeface="Arial" pitchFamily="34" charset="0"/>
-                <a:ea typeface="Arial" pitchFamily="34" charset="-122"/>
-                <a:cs typeface="Arial" pitchFamily="34" charset="-120"/>
-              </a:rPr>
-              <a:t>One agent, eight task types</a:t>
-            </a:r>
-            <a:endParaRPr lang="en-US" sz="1650" dirty="0"/>
-          </a:p>
-        </p:txBody>
-      </p:sp>
-      <p:sp>
-        <p:nvSpPr>
-          <p:cNvPr id="10" name="Text 6"/>
-          <p:cNvSpPr/>
-          <p:nvPr/>
-        </p:nvSpPr>
-        <p:spPr>
-          <a:xfrm>
-            <a:off x="1600200" y="3255264"/>
-            <a:ext cx="5212080" cy="777240"/>
-          </a:xfrm>
-          <a:prstGeom prst="rect">
-            <a:avLst/>
-          </a:prstGeom>
-          <a:noFill/>
-          <a:ln/>
-        </p:spPr>
-        <p:txBody>
-          <a:bodyPr wrap="square" lIns="0" tIns="0" rIns="0" bIns="0" rtlCol="0" anchor="t"/>
-          <a:lstStyle/>
-          <a:p>
-            <a:pPr indent="0" marL="0">
-              <a:lnSpc>
-                <a:spcPct val="112000"/>
-              </a:lnSpc>
-              <a:buNone/>
-            </a:pPr>
-            <a:r>
-              <a:rPr lang="en-US" sz="1300" dirty="0">
-                <a:solidFill>
-                  <a:srgbClr val="63686E"/>
-                </a:solidFill>
-                <a:latin typeface="Arial" pitchFamily="34" charset="0"/>
-                <a:ea typeface="Arial" pitchFamily="34" charset="-122"/>
-                <a:cs typeface="Arial" pitchFamily="34" charset="-120"/>
-              </a:rPr>
-              <a:t>Track 1: answer 19 varied tasks — math, code generation &amp; debugging, logic, NER, sentiment, summarisation, factual Q&amp;A — above an accuracy gate.</a:t>
-            </a:r>
-            <a:endParaRPr lang="en-US" sz="1300" dirty="0"/>
-          </a:p>
-        </p:txBody>
-      </p:sp>
-      <p:sp>
-        <p:nvSpPr>
-          <p:cNvPr id="11" name="Shape 7"/>
-          <p:cNvSpPr/>
-          <p:nvPr/>
-        </p:nvSpPr>
-        <p:spPr>
-          <a:xfrm>
-            <a:off x="822960" y="4453128"/>
-            <a:ext cx="530352" cy="530352"/>
-          </a:xfrm>
-          <a:prstGeom prst="ellipse">
-            <a:avLst/>
-          </a:prstGeom>
-          <a:solidFill>
-            <a:srgbClr val="FDEBEC"/>
-          </a:solidFill>
-          <a:ln/>
-        </p:spPr>
-      </p:sp>
-      <p:pic>
-        <p:nvPicPr>
-          <p:cNvPr id="12" name="Image 2" descr="preencoded.png">    </p:cNvPr>
+          <p:cNvPr id="4" name="Image 0" descr="preencoded.png"/>
           <p:cNvPicPr>
             <a:picLocks noChangeAspect="1"/>
           </p:cNvPicPr>
@@ -3617,6 +3136,256 @@
         </p:blipFill>
         <p:spPr>
           <a:xfrm>
+            <a:off x="950244" y="1700052"/>
+            <a:ext cx="275783" cy="275783"/>
+          </a:xfrm>
+          <a:prstGeom prst="rect">
+            <a:avLst/>
+          </a:prstGeom>
+        </p:spPr>
+      </p:pic>
+      <p:sp>
+        <p:nvSpPr>
+          <p:cNvPr id="5" name="Text 2"/>
+          <p:cNvSpPr/>
+          <p:nvPr/>
+        </p:nvSpPr>
+        <p:spPr>
+          <a:xfrm>
+            <a:off x="1600200" y="1554480"/>
+            <a:ext cx="5212080" cy="292608"/>
+          </a:xfrm>
+          <a:prstGeom prst="rect">
+            <a:avLst/>
+          </a:prstGeom>
+          <a:noFill/>
+          <a:ln/>
+        </p:spPr>
+        <p:txBody>
+          <a:bodyPr wrap="square" lIns="0" tIns="0" rIns="0" bIns="0" rtlCol="0" anchor="ctr"/>
+          <a:lstStyle/>
+          <a:p>
+            <a:pPr marL="0" indent="0">
+              <a:buNone/>
+            </a:pPr>
+            <a:r>
+              <a:rPr lang="en-US" sz="1650" b="1" dirty="0">
+                <a:solidFill>
+                  <a:srgbClr val="26282C"/>
+                </a:solidFill>
+                <a:latin typeface="Arial" pitchFamily="34" charset="0"/>
+                <a:ea typeface="Arial" pitchFamily="34" charset="-122"/>
+                <a:cs typeface="Arial" pitchFamily="34" charset="-120"/>
+              </a:rPr>
+              <a:t>AI spend control — without a quality tax</a:t>
+            </a:r>
+            <a:endParaRPr lang="en-US" sz="1650" dirty="0"/>
+          </a:p>
+        </p:txBody>
+      </p:sp>
+      <p:sp>
+        <p:nvSpPr>
+          <p:cNvPr id="6" name="Text 3"/>
+          <p:cNvSpPr/>
+          <p:nvPr/>
+        </p:nvSpPr>
+        <p:spPr>
+          <a:xfrm>
+            <a:off x="1600200" y="1883664"/>
+            <a:ext cx="5212080" cy="777240"/>
+          </a:xfrm>
+          <a:prstGeom prst="rect">
+            <a:avLst/>
+          </a:prstGeom>
+          <a:noFill/>
+          <a:ln/>
+        </p:spPr>
+        <p:txBody>
+          <a:bodyPr wrap="square" lIns="0" tIns="0" rIns="0" bIns="0" rtlCol="0" anchor="t"/>
+          <a:lstStyle/>
+          <a:p>
+            <a:pPr marL="0" indent="0">
+              <a:lnSpc>
+                <a:spcPct val="112000"/>
+              </a:lnSpc>
+              <a:buNone/>
+            </a:pPr>
+            <a:r>
+              <a:rPr lang="en-US" sz="1300" dirty="0">
+                <a:solidFill>
+                  <a:srgbClr val="63686E"/>
+                </a:solidFill>
+                <a:latin typeface="Arial" pitchFamily="34" charset="0"/>
+                <a:ea typeface="Arial" pitchFamily="34" charset="-122"/>
+                <a:cs typeface="Arial" pitchFamily="34" charset="-120"/>
+              </a:rPr>
+              <a:t>Enterprises want to cut LLM inference cost, but every saved token is worthless if accuracy drops below the bar.</a:t>
+            </a:r>
+            <a:endParaRPr lang="en-US" sz="1300" dirty="0"/>
+          </a:p>
+        </p:txBody>
+      </p:sp>
+      <p:sp>
+        <p:nvSpPr>
+          <p:cNvPr id="7" name="Shape 4"/>
+          <p:cNvSpPr/>
+          <p:nvPr/>
+        </p:nvSpPr>
+        <p:spPr>
+          <a:xfrm>
+            <a:off x="822960" y="2944368"/>
+            <a:ext cx="530352" cy="530352"/>
+          </a:xfrm>
+          <a:prstGeom prst="ellipse">
+            <a:avLst/>
+          </a:prstGeom>
+          <a:solidFill>
+            <a:srgbClr val="FDEBEC"/>
+          </a:solidFill>
+          <a:ln/>
+        </p:spPr>
+      </p:sp>
+      <p:pic>
+        <p:nvPicPr>
+          <p:cNvPr id="8" name="Image 1" descr="preencoded.png"/>
+          <p:cNvPicPr>
+            <a:picLocks noChangeAspect="1"/>
+          </p:cNvPicPr>
+          <p:nvPr/>
+        </p:nvPicPr>
+        <p:blipFill>
+          <a:blip r:embed="rId4"/>
+          <a:stretch>
+            <a:fillRect/>
+          </a:stretch>
+        </p:blipFill>
+        <p:spPr>
+          <a:xfrm>
+            <a:off x="950244" y="3071652"/>
+            <a:ext cx="275783" cy="275783"/>
+          </a:xfrm>
+          <a:prstGeom prst="rect">
+            <a:avLst/>
+          </a:prstGeom>
+        </p:spPr>
+      </p:pic>
+      <p:sp>
+        <p:nvSpPr>
+          <p:cNvPr id="9" name="Text 5"/>
+          <p:cNvSpPr/>
+          <p:nvPr/>
+        </p:nvSpPr>
+        <p:spPr>
+          <a:xfrm>
+            <a:off x="1600200" y="2926080"/>
+            <a:ext cx="5212080" cy="292608"/>
+          </a:xfrm>
+          <a:prstGeom prst="rect">
+            <a:avLst/>
+          </a:prstGeom>
+          <a:noFill/>
+          <a:ln/>
+        </p:spPr>
+        <p:txBody>
+          <a:bodyPr wrap="square" lIns="0" tIns="0" rIns="0" bIns="0" rtlCol="0" anchor="ctr"/>
+          <a:lstStyle/>
+          <a:p>
+            <a:pPr marL="0" indent="0">
+              <a:buNone/>
+            </a:pPr>
+            <a:r>
+              <a:rPr lang="en-US" sz="1650" b="1" dirty="0">
+                <a:solidFill>
+                  <a:srgbClr val="26282C"/>
+                </a:solidFill>
+                <a:latin typeface="Arial" pitchFamily="34" charset="0"/>
+                <a:ea typeface="Arial" pitchFamily="34" charset="-122"/>
+                <a:cs typeface="Arial" pitchFamily="34" charset="-120"/>
+              </a:rPr>
+              <a:t>One agent, eight task types</a:t>
+            </a:r>
+            <a:endParaRPr lang="en-US" sz="1650" dirty="0"/>
+          </a:p>
+        </p:txBody>
+      </p:sp>
+      <p:sp>
+        <p:nvSpPr>
+          <p:cNvPr id="10" name="Text 6"/>
+          <p:cNvSpPr/>
+          <p:nvPr/>
+        </p:nvSpPr>
+        <p:spPr>
+          <a:xfrm>
+            <a:off x="1600200" y="3255264"/>
+            <a:ext cx="5212080" cy="777240"/>
+          </a:xfrm>
+          <a:prstGeom prst="rect">
+            <a:avLst/>
+          </a:prstGeom>
+          <a:noFill/>
+          <a:ln/>
+        </p:spPr>
+        <p:txBody>
+          <a:bodyPr wrap="square" lIns="0" tIns="0" rIns="0" bIns="0" rtlCol="0" anchor="t"/>
+          <a:lstStyle/>
+          <a:p>
+            <a:pPr marL="0" indent="0">
+              <a:lnSpc>
+                <a:spcPct val="112000"/>
+              </a:lnSpc>
+              <a:buNone/>
+            </a:pPr>
+            <a:r>
+              <a:rPr lang="en-US" sz="1300" dirty="0">
+                <a:solidFill>
+                  <a:srgbClr val="63686E"/>
+                </a:solidFill>
+                <a:latin typeface="Arial" pitchFamily="34" charset="0"/>
+                <a:ea typeface="Arial" pitchFamily="34" charset="-122"/>
+                <a:cs typeface="Arial" pitchFamily="34" charset="-120"/>
+              </a:rPr>
+              <a:t>Track 1: answer 19 varied tasks — math, code generation &amp; debugging, logic, NER, sentiment, summarisation, factual Q&amp;A — above an accuracy gate.</a:t>
+            </a:r>
+            <a:endParaRPr lang="en-US" sz="1300" dirty="0"/>
+          </a:p>
+        </p:txBody>
+      </p:sp>
+      <p:sp>
+        <p:nvSpPr>
+          <p:cNvPr id="11" name="Shape 7"/>
+          <p:cNvSpPr/>
+          <p:nvPr/>
+        </p:nvSpPr>
+        <p:spPr>
+          <a:xfrm>
+            <a:off x="822960" y="4453128"/>
+            <a:ext cx="530352" cy="530352"/>
+          </a:xfrm>
+          <a:prstGeom prst="ellipse">
+            <a:avLst/>
+          </a:prstGeom>
+          <a:solidFill>
+            <a:srgbClr val="FDEBEC"/>
+          </a:solidFill>
+          <a:ln/>
+        </p:spPr>
+      </p:sp>
+      <p:pic>
+        <p:nvPicPr>
+          <p:cNvPr id="12" name="Image 2" descr="preencoded.png"/>
+          <p:cNvPicPr>
+            <a:picLocks noChangeAspect="1"/>
+          </p:cNvPicPr>
+          <p:nvPr/>
+        </p:nvPicPr>
+        <p:blipFill>
+          <a:blip r:embed="rId5"/>
+          <a:stretch>
+            <a:fillRect/>
+          </a:stretch>
+        </p:blipFill>
+        <p:spPr>
+          <a:xfrm>
             <a:off x="950244" y="4580412"/>
             <a:ext cx="275783" cy="275783"/>
           </a:xfrm>
@@ -3646,7 +3415,7 @@
           <a:bodyPr wrap="square" lIns="0" tIns="0" rIns="0" bIns="0" rtlCol="0" anchor="ctr"/>
           <a:lstStyle/>
           <a:p>
-            <a:pPr indent="0" marL="0">
+            <a:pPr marL="0" indent="0">
               <a:buNone/>
             </a:pPr>
             <a:r>
@@ -3685,7 +3454,7 @@
           <a:bodyPr wrap="square" lIns="0" tIns="0" rIns="0" bIns="0" rtlCol="0" anchor="t"/>
           <a:lstStyle/>
           <a:p>
-            <a:pPr indent="0" marL="0">
+            <a:pPr marL="0" indent="0">
               <a:lnSpc>
                 <a:spcPct val="112000"/>
               </a:lnSpc>
@@ -3727,7 +3496,7 @@
           </a:solidFill>
           <a:ln/>
           <a:effectLst>
-            <a:outerShdw sx="100000" sy="100000" kx="0" ky="0" algn="bl" rotWithShape="0" blurRad="88900" dist="25400" dir="5400000">
+            <a:outerShdw blurRad="88900" dist="25400" dir="5400000" algn="bl" rotWithShape="0">
               <a:srgbClr val="9AA0A6">
                 <a:alpha val="30000"/>
               </a:srgbClr>
@@ -3756,11 +3525,11 @@
           <a:bodyPr wrap="square" lIns="0" tIns="0" rIns="0" bIns="0" rtlCol="0" anchor="ctr"/>
           <a:lstStyle/>
           <a:p>
-            <a:pPr indent="0" marL="0">
-              <a:buNone/>
-            </a:pPr>
-            <a:r>
-              <a:rPr lang="en-US" sz="1200" b="1" spc="300" kern="0" dirty="0">
+            <a:pPr marL="0" indent="0">
+              <a:buNone/>
+            </a:pPr>
+            <a:r>
+              <a:rPr lang="en-US" sz="1200" b="1" kern="0" spc="300" dirty="0">
                 <a:solidFill>
                   <a:srgbClr val="B9BEC4"/>
                 </a:solidFill>
@@ -3795,7 +3564,7 @@
           <a:bodyPr wrap="square" lIns="0" tIns="0" rIns="0" bIns="0" rtlCol="0" anchor="ctr"/>
           <a:lstStyle/>
           <a:p>
-            <a:pPr indent="0" marL="0">
+            <a:pPr marL="0" indent="0">
               <a:buNone/>
             </a:pPr>
             <a:r>
@@ -3834,7 +3603,7 @@
           <a:bodyPr wrap="square" lIns="0" tIns="0" rIns="0" bIns="0" rtlCol="0" anchor="ctr"/>
           <a:lstStyle/>
           <a:p>
-            <a:pPr indent="0" marL="0">
+            <a:pPr marL="0" indent="0">
               <a:buNone/>
             </a:pPr>
             <a:r>
@@ -3873,7 +3642,7 @@
           <a:bodyPr wrap="square" lIns="0" tIns="0" rIns="0" bIns="0" rtlCol="0" anchor="ctr"/>
           <a:lstStyle/>
           <a:p>
-            <a:pPr indent="0" marL="0">
+            <a:pPr marL="0" indent="0">
               <a:buNone/>
             </a:pPr>
             <a:r>
@@ -3912,7 +3681,7 @@
           <a:bodyPr wrap="square" lIns="0" tIns="0" rIns="0" bIns="0" rtlCol="0" anchor="ctr"/>
           <a:lstStyle/>
           <a:p>
-            <a:pPr indent="0" marL="0">
+            <a:pPr marL="0" indent="0">
               <a:buNone/>
             </a:pPr>
             <a:r>
@@ -3951,7 +3720,7 @@
           <a:bodyPr wrap="square" lIns="0" tIns="0" rIns="0" bIns="0" rtlCol="0" anchor="ctr"/>
           <a:lstStyle/>
           <a:p>
-            <a:pPr indent="0" marL="0">
+            <a:pPr marL="0" indent="0">
               <a:buNone/>
             </a:pPr>
             <a:r>
@@ -3990,7 +3759,7 @@
           <a:bodyPr wrap="square" lIns="0" tIns="0" rIns="0" bIns="0" rtlCol="0" anchor="ctr"/>
           <a:lstStyle/>
           <a:p>
-            <a:pPr indent="0" marL="0">
+            <a:pPr marL="0" indent="0">
               <a:buNone/>
             </a:pPr>
             <a:r>
@@ -4029,7 +3798,7 @@
           <a:bodyPr wrap="square" lIns="0" tIns="0" rIns="0" bIns="0" rtlCol="0" anchor="ctr"/>
           <a:lstStyle/>
           <a:p>
-            <a:pPr indent="0" marL="0">
+            <a:pPr marL="0" indent="0">
               <a:buNone/>
             </a:pPr>
             <a:r>
@@ -4068,7 +3837,7 @@
           <a:bodyPr wrap="square" lIns="0" tIns="0" rIns="0" bIns="0" rtlCol="0" anchor="ctr"/>
           <a:lstStyle/>
           <a:p>
-            <a:pPr indent="0" marL="0">
+            <a:pPr marL="0" indent="0">
               <a:buNone/>
             </a:pPr>
             <a:r>
@@ -4130,7 +3899,7 @@
           <a:bodyPr wrap="square" lIns="0" tIns="0" rIns="0" bIns="0" rtlCol="0" anchor="ctr"/>
           <a:lstStyle/>
           <a:p>
-            <a:pPr indent="0" marL="0">
+            <a:pPr marL="0" indent="0">
               <a:lnSpc>
                 <a:spcPct val="115000"/>
               </a:lnSpc>
@@ -4167,6 +3936,7 @@
         <a:solidFill>
           <a:srgbClr val="FFFFFF"/>
         </a:solidFill>
+        <a:effectLst/>
       </p:bgPr>
     </p:bg>
     <p:spTree>
@@ -4204,7 +3974,7 @@
           <a:bodyPr wrap="square" lIns="0" tIns="0" rIns="0" bIns="0" rtlCol="0" anchor="ctr"/>
           <a:lstStyle/>
           <a:p>
-            <a:pPr indent="0" marL="0">
+            <a:pPr marL="0" indent="0">
               <a:lnSpc>
                 <a:spcPct val="105000"/>
               </a:lnSpc>
@@ -4222,12 +3992,6 @@
               <a:t>Don’t route to the cheapest cloud model.
 </a:t>
             </a:r>
-            <a:pPr indent="0" marL="0">
-              <a:lnSpc>
-                <a:spcPct val="105000"/>
-              </a:lnSpc>
-              <a:buNone/>
-            </a:pPr>
             <a:r>
               <a:rPr lang="en-US" sz="2900" b="1" dirty="0">
                 <a:solidFill>
@@ -4345,7 +4109,7 @@
           <a:bodyPr wrap="square" lIns="0" tIns="0" rIns="0" bIns="0" rtlCol="0" anchor="ctr"/>
           <a:lstStyle/>
           <a:p>
-            <a:pPr algn="ctr" indent="0" marL="0">
+            <a:pPr marL="0" indent="0" algn="ctr">
               <a:buNone/>
             </a:pPr>
             <a:r>
@@ -4384,7 +4148,7 @@
           <a:bodyPr wrap="square" lIns="0" tIns="0" rIns="0" bIns="0" rtlCol="0" anchor="ctr"/>
           <a:lstStyle/>
           <a:p>
-            <a:pPr algn="ctr" indent="0" marL="0">
+            <a:pPr marL="0" indent="0" algn="ctr">
               <a:buNone/>
             </a:pPr>
             <a:r>
@@ -4452,7 +4216,7 @@
             <a:prstDash val="solid"/>
           </a:ln>
           <a:effectLst>
-            <a:outerShdw sx="100000" sy="100000" kx="0" ky="0" algn="bl" rotWithShape="0" blurRad="88900" dist="25400" dir="5400000">
+            <a:outerShdw blurRad="88900" dist="25400" dir="5400000" algn="bl" rotWithShape="0">
               <a:srgbClr val="9AA0A6">
                 <a:alpha val="30000"/>
               </a:srgbClr>
@@ -4481,11 +4245,11 @@
           <a:bodyPr wrap="square" lIns="0" tIns="0" rIns="0" bIns="0" rtlCol="0" anchor="ctr"/>
           <a:lstStyle/>
           <a:p>
-            <a:pPr algn="ctr" indent="0" marL="0">
-              <a:buNone/>
-            </a:pPr>
-            <a:r>
-              <a:rPr lang="en-US" sz="1200" b="1" spc="300" kern="0" dirty="0">
+            <a:pPr marL="0" indent="0" algn="ctr">
+              <a:buNone/>
+            </a:pPr>
+            <a:r>
+              <a:rPr lang="en-US" sz="1200" b="1" kern="0" spc="300" dirty="0">
                 <a:solidFill>
                   <a:srgbClr val="26282C"/>
                 </a:solidFill>
@@ -4520,7 +4284,7 @@
           <a:bodyPr wrap="square" lIns="0" tIns="0" rIns="0" bIns="0" rtlCol="0" anchor="ctr"/>
           <a:lstStyle/>
           <a:p>
-            <a:pPr algn="ctr" indent="0" marL="0">
+            <a:pPr marL="0" indent="0" algn="ctr">
               <a:buNone/>
             </a:pPr>
             <a:r>
@@ -4581,7 +4345,7 @@
           <a:bodyPr wrap="square" lIns="0" tIns="0" rIns="0" bIns="0" rtlCol="0" anchor="ctr"/>
           <a:lstStyle/>
           <a:p>
-            <a:pPr algn="ctr" indent="0" marL="0">
+            <a:pPr marL="0" indent="0" algn="ctr">
               <a:buNone/>
             </a:pPr>
             <a:r>
@@ -4642,7 +4406,7 @@
           <a:bodyPr wrap="square" lIns="0" tIns="0" rIns="0" bIns="0" rtlCol="0" anchor="ctr"/>
           <a:lstStyle/>
           <a:p>
-            <a:pPr algn="ctr" indent="0" marL="0">
+            <a:pPr marL="0" indent="0" algn="ctr">
               <a:buNone/>
             </a:pPr>
             <a:r>
@@ -4681,7 +4445,7 @@
           <a:bodyPr wrap="square" lIns="0" tIns="0" rIns="0" bIns="0" rtlCol="0" anchor="ctr"/>
           <a:lstStyle/>
           <a:p>
-            <a:pPr algn="ctr" indent="0" marL="0">
+            <a:pPr marL="0" indent="0" algn="ctr">
               <a:buNone/>
             </a:pPr>
             <a:r>
@@ -4720,7 +4484,7 @@
           <a:bodyPr wrap="square" lIns="0" tIns="0" rIns="0" bIns="0" rtlCol="0" anchor="ctr"/>
           <a:lstStyle/>
           <a:p>
-            <a:pPr algn="ctr" indent="0" marL="0">
+            <a:pPr marL="0" indent="0" algn="ctr">
               <a:buNone/>
             </a:pPr>
             <a:r>
@@ -4783,7 +4547,7 @@
           <a:bodyPr wrap="square" lIns="0" tIns="0" rIns="0" bIns="0" rtlCol="0" anchor="ctr"/>
           <a:lstStyle/>
           <a:p>
-            <a:pPr algn="ctr" indent="0" marL="0">
+            <a:pPr marL="0" indent="0" algn="ctr">
               <a:buNone/>
             </a:pPr>
             <a:r>
@@ -4844,7 +4608,7 @@
           <a:bodyPr wrap="square" lIns="0" tIns="0" rIns="0" bIns="0" rtlCol="0" anchor="ctr"/>
           <a:lstStyle/>
           <a:p>
-            <a:pPr algn="ctr" indent="0" marL="0">
+            <a:pPr marL="0" indent="0" algn="ctr">
               <a:buNone/>
             </a:pPr>
             <a:r>
@@ -4883,7 +4647,7 @@
           <a:bodyPr wrap="square" lIns="0" tIns="0" rIns="0" bIns="0" rtlCol="0" anchor="ctr"/>
           <a:lstStyle/>
           <a:p>
-            <a:pPr algn="ctr" indent="0" marL="0">
+            <a:pPr marL="0" indent="0" algn="ctr">
               <a:buNone/>
             </a:pPr>
             <a:r>
@@ -4949,7 +4713,7 @@
           <a:bodyPr wrap="square" lIns="0" tIns="0" rIns="0" bIns="0" rtlCol="0" anchor="ctr"/>
           <a:lstStyle/>
           <a:p>
-            <a:pPr algn="ctr" indent="0" marL="0">
+            <a:pPr marL="0" indent="0" algn="ctr">
               <a:buNone/>
             </a:pPr>
             <a:r>
@@ -4988,7 +4752,7 @@
           <a:bodyPr wrap="square" lIns="0" tIns="0" rIns="0" bIns="0" rtlCol="0" anchor="ctr"/>
           <a:lstStyle/>
           <a:p>
-            <a:pPr algn="ctr" indent="0" marL="0">
+            <a:pPr marL="0" indent="0" algn="ctr">
               <a:buNone/>
             </a:pPr>
             <a:r>
@@ -5051,7 +4815,7 @@
           <a:bodyPr wrap="square" lIns="0" tIns="0" rIns="0" bIns="0" rtlCol="0" anchor="ctr"/>
           <a:lstStyle/>
           <a:p>
-            <a:pPr indent="0" marL="0">
+            <a:pPr marL="0" indent="0">
               <a:lnSpc>
                 <a:spcPct val="120000"/>
               </a:lnSpc>
@@ -5088,6 +4852,7 @@
         <a:solidFill>
           <a:srgbClr val="FFFFFF"/>
         </a:solidFill>
+        <a:effectLst/>
       </p:bgPr>
     </p:bg>
     <p:spTree>
@@ -5125,7 +4890,7 @@
           <a:bodyPr wrap="square" lIns="0" tIns="0" rIns="0" bIns="0" rtlCol="0" anchor="ctr"/>
           <a:lstStyle/>
           <a:p>
-            <a:pPr indent="0" marL="0">
+            <a:pPr marL="0" indent="0">
               <a:buNone/>
             </a:pPr>
             <a:r>
@@ -5164,7 +4929,7 @@
           <a:bodyPr wrap="square" lIns="0" tIns="0" rIns="0" bIns="0" rtlCol="0" anchor="ctr"/>
           <a:lstStyle/>
           <a:p>
-            <a:pPr indent="0" marL="0">
+            <a:pPr marL="0" indent="0">
               <a:buNone/>
             </a:pPr>
             <a:r>
@@ -5226,301 +4991,7 @@
       </p:sp>
       <p:pic>
         <p:nvPicPr>
-          <p:cNvPr id="6" name="Image 0" descr="preencoded.png">    </p:cNvPr>
-          <p:cNvPicPr>
-            <a:picLocks noChangeAspect="1"/>
-          </p:cNvPicPr>
-          <p:nvPr/>
-        </p:nvPicPr>
-        <p:blipFill>
-          <a:blip r:embed="rId1"/>
-          <a:stretch>
-            <a:fillRect/>
-          </a:stretch>
-        </p:blipFill>
-        <p:spPr>
-          <a:xfrm>
-            <a:off x="1188720" y="1847088"/>
-            <a:ext cx="237744" cy="237744"/>
-          </a:xfrm>
-          <a:prstGeom prst="rect">
-            <a:avLst/>
-          </a:prstGeom>
-        </p:spPr>
-      </p:pic>
-      <p:sp>
-        <p:nvSpPr>
-          <p:cNvPr id="7" name="Text 4"/>
-          <p:cNvSpPr/>
-          <p:nvPr/>
-        </p:nvSpPr>
-        <p:spPr>
-          <a:xfrm>
-            <a:off x="1719072" y="1773936"/>
-            <a:ext cx="4087368" cy="292608"/>
-          </a:xfrm>
-          <a:prstGeom prst="rect">
-            <a:avLst/>
-          </a:prstGeom>
-          <a:noFill/>
-          <a:ln/>
-        </p:spPr>
-        <p:txBody>
-          <a:bodyPr wrap="square" lIns="0" tIns="0" rIns="0" bIns="0" rtlCol="0" anchor="ctr"/>
-          <a:lstStyle/>
-          <a:p>
-            <a:pPr indent="0" marL="0">
-              <a:buNone/>
-            </a:pPr>
-            <a:r>
-              <a:rPr lang="en-US" sz="1650" b="1" dirty="0">
-                <a:solidFill>
-                  <a:srgbClr val="26282C"/>
-                </a:solidFill>
-                <a:latin typeface="Arial" pitchFamily="34" charset="0"/>
-                <a:ea typeface="Arial" pitchFamily="34" charset="-122"/>
-                <a:cs typeface="Arial" pitchFamily="34" charset="-120"/>
-              </a:rPr>
-              <a:t>Math</a:t>
-            </a:r>
-            <a:endParaRPr lang="en-US" sz="1650" dirty="0"/>
-          </a:p>
-        </p:txBody>
-      </p:sp>
-      <p:sp>
-        <p:nvSpPr>
-          <p:cNvPr id="8" name="Text 5"/>
-          <p:cNvSpPr/>
-          <p:nvPr/>
-        </p:nvSpPr>
-        <p:spPr>
-          <a:xfrm>
-            <a:off x="1719072" y="2139696"/>
-            <a:ext cx="4041648" cy="1005840"/>
-          </a:xfrm>
-          <a:prstGeom prst="rect">
-            <a:avLst/>
-          </a:prstGeom>
-          <a:noFill/>
-          <a:ln/>
-        </p:spPr>
-        <p:txBody>
-          <a:bodyPr wrap="square" lIns="0" tIns="0" rIns="0" bIns="0" rtlCol="0" anchor="t"/>
-          <a:lstStyle/>
-          <a:p>
-            <a:pPr indent="0" marL="0">
-              <a:lnSpc>
-                <a:spcPct val="115000"/>
-              </a:lnSpc>
-              <a:buNone/>
-            </a:pPr>
-            <a:r>
-              <a:rPr lang="en-US" sz="1225" dirty="0">
-                <a:solidFill>
-                  <a:srgbClr val="63686E"/>
-                </a:solidFill>
-                <a:latin typeface="Arial" pitchFamily="34" charset="0"/>
-                <a:ea typeface="Arial" pitchFamily="34" charset="-122"/>
-                <a:cs typeface="Arial" pitchFamily="34" charset="-120"/>
-              </a:rPr>
-              <a:t>The model writes a Python program. We execute it, then majority-vote the computed number across samples.</a:t>
-            </a:r>
-            <a:endParaRPr lang="en-US" sz="1225" dirty="0"/>
-          </a:p>
-        </p:txBody>
-      </p:sp>
-      <p:sp>
-        <p:nvSpPr>
-          <p:cNvPr id="9" name="Shape 6"/>
-          <p:cNvSpPr/>
-          <p:nvPr/>
-        </p:nvSpPr>
-        <p:spPr>
-          <a:xfrm>
-            <a:off x="6327648" y="1481328"/>
-            <a:ext cx="5230368" cy="1828800"/>
-          </a:xfrm>
-          <a:prstGeom prst="roundRect">
-            <a:avLst>
-              <a:gd name="adj" fmla="val 5000"/>
-            </a:avLst>
-          </a:prstGeom>
-          <a:solidFill>
-            <a:srgbClr val="F6F7F8"/>
-          </a:solidFill>
-          <a:ln/>
-        </p:spPr>
-      </p:sp>
-      <p:sp>
-        <p:nvSpPr>
-          <p:cNvPr id="10" name="Shape 7"/>
-          <p:cNvSpPr/>
-          <p:nvPr/>
-        </p:nvSpPr>
-        <p:spPr>
-          <a:xfrm>
-            <a:off x="6583680" y="1737360"/>
-            <a:ext cx="457200" cy="457200"/>
-          </a:xfrm>
-          <a:prstGeom prst="ellipse">
-            <a:avLst/>
-          </a:prstGeom>
-          <a:solidFill>
-            <a:srgbClr val="FDEBEC"/>
-          </a:solidFill>
-          <a:ln/>
-        </p:spPr>
-      </p:sp>
-      <p:pic>
-        <p:nvPicPr>
-          <p:cNvPr id="11" name="Image 1" descr="preencoded.png">    </p:cNvPr>
-          <p:cNvPicPr>
-            <a:picLocks noChangeAspect="1"/>
-          </p:cNvPicPr>
-          <p:nvPr/>
-        </p:nvPicPr>
-        <p:blipFill>
-          <a:blip r:embed="rId2"/>
-          <a:stretch>
-            <a:fillRect/>
-          </a:stretch>
-        </p:blipFill>
-        <p:spPr>
-          <a:xfrm>
-            <a:off x="6693408" y="1847088"/>
-            <a:ext cx="237744" cy="237744"/>
-          </a:xfrm>
-          <a:prstGeom prst="rect">
-            <a:avLst/>
-          </a:prstGeom>
-        </p:spPr>
-      </p:pic>
-      <p:sp>
-        <p:nvSpPr>
-          <p:cNvPr id="12" name="Text 8"/>
-          <p:cNvSpPr/>
-          <p:nvPr/>
-        </p:nvSpPr>
-        <p:spPr>
-          <a:xfrm>
-            <a:off x="7223760" y="1773936"/>
-            <a:ext cx="4087368" cy="292608"/>
-          </a:xfrm>
-          <a:prstGeom prst="rect">
-            <a:avLst/>
-          </a:prstGeom>
-          <a:noFill/>
-          <a:ln/>
-        </p:spPr>
-        <p:txBody>
-          <a:bodyPr wrap="square" lIns="0" tIns="0" rIns="0" bIns="0" rtlCol="0" anchor="ctr"/>
-          <a:lstStyle/>
-          <a:p>
-            <a:pPr indent="0" marL="0">
-              <a:buNone/>
-            </a:pPr>
-            <a:r>
-              <a:rPr lang="en-US" sz="1650" b="1" dirty="0">
-                <a:solidFill>
-                  <a:srgbClr val="26282C"/>
-                </a:solidFill>
-                <a:latin typeface="Arial" pitchFamily="34" charset="0"/>
-                <a:ea typeface="Arial" pitchFamily="34" charset="-122"/>
-                <a:cs typeface="Arial" pitchFamily="34" charset="-120"/>
-              </a:rPr>
-              <a:t>Code</a:t>
-            </a:r>
-            <a:endParaRPr lang="en-US" sz="1650" dirty="0"/>
-          </a:p>
-        </p:txBody>
-      </p:sp>
-      <p:sp>
-        <p:nvSpPr>
-          <p:cNvPr id="13" name="Text 9"/>
-          <p:cNvSpPr/>
-          <p:nvPr/>
-        </p:nvSpPr>
-        <p:spPr>
-          <a:xfrm>
-            <a:off x="7223760" y="2139696"/>
-            <a:ext cx="4041648" cy="1005840"/>
-          </a:xfrm>
-          <a:prstGeom prst="rect">
-            <a:avLst/>
-          </a:prstGeom>
-          <a:noFill/>
-          <a:ln/>
-        </p:spPr>
-        <p:txBody>
-          <a:bodyPr wrap="square" lIns="0" tIns="0" rIns="0" bIns="0" rtlCol="0" anchor="t"/>
-          <a:lstStyle/>
-          <a:p>
-            <a:pPr indent="0" marL="0">
-              <a:lnSpc>
-                <a:spcPct val="115000"/>
-              </a:lnSpc>
-              <a:buNone/>
-            </a:pPr>
-            <a:r>
-              <a:rPr lang="en-US" sz="1225" dirty="0">
-                <a:solidFill>
-                  <a:srgbClr val="63686E"/>
-                </a:solidFill>
-                <a:latin typeface="Arial" pitchFamily="34" charset="0"/>
-                <a:ea typeface="Arial" pitchFamily="34" charset="-122"/>
-                <a:cs typeface="Arial" pitchFamily="34" charset="-120"/>
-              </a:rPr>
-              <a:t>Two independently sampled implementations must agree on observed behavior — disagreement triggers a third and a vote.</a:t>
-            </a:r>
-            <a:endParaRPr lang="en-US" sz="1225" dirty="0"/>
-          </a:p>
-        </p:txBody>
-      </p:sp>
-      <p:sp>
-        <p:nvSpPr>
-          <p:cNvPr id="14" name="Shape 10"/>
-          <p:cNvSpPr/>
-          <p:nvPr/>
-        </p:nvSpPr>
-        <p:spPr>
-          <a:xfrm>
-            <a:off x="822960" y="3584448"/>
-            <a:ext cx="5230368" cy="1828800"/>
-          </a:xfrm>
-          <a:prstGeom prst="roundRect">
-            <a:avLst>
-              <a:gd name="adj" fmla="val 5000"/>
-            </a:avLst>
-          </a:prstGeom>
-          <a:solidFill>
-            <a:srgbClr val="F6F7F8"/>
-          </a:solidFill>
-          <a:ln/>
-        </p:spPr>
-      </p:sp>
-      <p:sp>
-        <p:nvSpPr>
-          <p:cNvPr id="15" name="Shape 11"/>
-          <p:cNvSpPr/>
-          <p:nvPr/>
-        </p:nvSpPr>
-        <p:spPr>
-          <a:xfrm>
-            <a:off x="1078992" y="3840480"/>
-            <a:ext cx="457200" cy="457200"/>
-          </a:xfrm>
-          <a:prstGeom prst="ellipse">
-            <a:avLst/>
-          </a:prstGeom>
-          <a:solidFill>
-            <a:srgbClr val="FDEBEC"/>
-          </a:solidFill>
-          <a:ln/>
-        </p:spPr>
-      </p:sp>
-      <p:pic>
-        <p:nvPicPr>
-          <p:cNvPr id="16" name="Image 2" descr="preencoded.png">    </p:cNvPr>
+          <p:cNvPr id="6" name="Image 0" descr="preencoded.png"/>
           <p:cNvPicPr>
             <a:picLocks noChangeAspect="1"/>
           </p:cNvPicPr>
@@ -5534,7 +5005,7 @@
         </p:blipFill>
         <p:spPr>
           <a:xfrm>
-            <a:off x="1188720" y="3950208"/>
+            <a:off x="1188720" y="1847088"/>
             <a:ext cx="237744" cy="237744"/>
           </a:xfrm>
           <a:prstGeom prst="rect">
@@ -5544,13 +5015,13 @@
       </p:pic>
       <p:sp>
         <p:nvSpPr>
-          <p:cNvPr id="17" name="Text 12"/>
-          <p:cNvSpPr/>
-          <p:nvPr/>
-        </p:nvSpPr>
-        <p:spPr>
-          <a:xfrm>
-            <a:off x="1719072" y="3877056"/>
+          <p:cNvPr id="7" name="Text 4"/>
+          <p:cNvSpPr/>
+          <p:nvPr/>
+        </p:nvSpPr>
+        <p:spPr>
+          <a:xfrm>
+            <a:off x="1719072" y="1773936"/>
             <a:ext cx="4087368" cy="292608"/>
           </a:xfrm>
           <a:prstGeom prst="rect">
@@ -5563,7 +5034,7 @@
           <a:bodyPr wrap="square" lIns="0" tIns="0" rIns="0" bIns="0" rtlCol="0" anchor="ctr"/>
           <a:lstStyle/>
           <a:p>
-            <a:pPr indent="0" marL="0">
+            <a:pPr marL="0" indent="0">
               <a:buNone/>
             </a:pPr>
             <a:r>
@@ -5575,7 +5046,7 @@
                 <a:ea typeface="Arial" pitchFamily="34" charset="-122"/>
                 <a:cs typeface="Arial" pitchFamily="34" charset="-120"/>
               </a:rPr>
-              <a:t>Logic</a:t>
+              <a:t>Math</a:t>
             </a:r>
             <a:endParaRPr lang="en-US" sz="1650" dirty="0"/>
           </a:p>
@@ -5583,13 +5054,13 @@
       </p:sp>
       <p:sp>
         <p:nvSpPr>
-          <p:cNvPr id="18" name="Text 13"/>
-          <p:cNvSpPr/>
-          <p:nvPr/>
-        </p:nvSpPr>
-        <p:spPr>
-          <a:xfrm>
-            <a:off x="1719072" y="4242816"/>
+          <p:cNvPr id="8" name="Text 5"/>
+          <p:cNvSpPr/>
+          <p:nvPr/>
+        </p:nvSpPr>
+        <p:spPr>
+          <a:xfrm>
+            <a:off x="1719072" y="2139696"/>
             <a:ext cx="4041648" cy="1005840"/>
           </a:xfrm>
           <a:prstGeom prst="rect">
@@ -5602,7 +5073,7 @@
           <a:bodyPr wrap="square" lIns="0" tIns="0" rIns="0" bIns="0" rtlCol="0" anchor="t"/>
           <a:lstStyle/>
           <a:p>
-            <a:pPr indent="0" marL="0">
+            <a:pPr marL="0" indent="0">
               <a:lnSpc>
                 <a:spcPct val="115000"/>
               </a:lnSpc>
@@ -5617,7 +5088,7 @@
                 <a:ea typeface="Arial" pitchFamily="34" charset="-122"/>
                 <a:cs typeface="Arial" pitchFamily="34" charset="-120"/>
               </a:rPr>
-              <a:t>Entities and constraints extracted to JSON, every assignment brute-forced — an answer ships only with a proven unique solution.</a:t>
+              <a:t>The model writes a Python program. We execute it, then majority-vote the computed number across samples.</a:t>
             </a:r>
             <a:endParaRPr lang="en-US" sz="1225" dirty="0"/>
           </a:p>
@@ -5625,13 +5096,13 @@
       </p:sp>
       <p:sp>
         <p:nvSpPr>
-          <p:cNvPr id="19" name="Shape 14"/>
-          <p:cNvSpPr/>
-          <p:nvPr/>
-        </p:nvSpPr>
-        <p:spPr>
-          <a:xfrm>
-            <a:off x="6327648" y="3584448"/>
+          <p:cNvPr id="9" name="Shape 6"/>
+          <p:cNvSpPr/>
+          <p:nvPr/>
+        </p:nvSpPr>
+        <p:spPr>
+          <a:xfrm>
+            <a:off x="6327648" y="1481328"/>
             <a:ext cx="5230368" cy="1828800"/>
           </a:xfrm>
           <a:prstGeom prst="roundRect">
@@ -5647,13 +5118,13 @@
       </p:sp>
       <p:sp>
         <p:nvSpPr>
-          <p:cNvPr id="20" name="Shape 15"/>
-          <p:cNvSpPr/>
-          <p:nvPr/>
-        </p:nvSpPr>
-        <p:spPr>
-          <a:xfrm>
-            <a:off x="6583680" y="3840480"/>
+          <p:cNvPr id="10" name="Shape 7"/>
+          <p:cNvSpPr/>
+          <p:nvPr/>
+        </p:nvSpPr>
+        <p:spPr>
+          <a:xfrm>
+            <a:off x="6583680" y="1737360"/>
             <a:ext cx="457200" cy="457200"/>
           </a:xfrm>
           <a:prstGeom prst="ellipse">
@@ -5667,7 +5138,7 @@
       </p:sp>
       <p:pic>
         <p:nvPicPr>
-          <p:cNvPr id="21" name="Image 3" descr="preencoded.png">    </p:cNvPr>
+          <p:cNvPr id="11" name="Image 1" descr="preencoded.png"/>
           <p:cNvPicPr>
             <a:picLocks noChangeAspect="1"/>
           </p:cNvPicPr>
@@ -5681,6 +5152,300 @@
         </p:blipFill>
         <p:spPr>
           <a:xfrm>
+            <a:off x="6693408" y="1847088"/>
+            <a:ext cx="237744" cy="237744"/>
+          </a:xfrm>
+          <a:prstGeom prst="rect">
+            <a:avLst/>
+          </a:prstGeom>
+        </p:spPr>
+      </p:pic>
+      <p:sp>
+        <p:nvSpPr>
+          <p:cNvPr id="12" name="Text 8"/>
+          <p:cNvSpPr/>
+          <p:nvPr/>
+        </p:nvSpPr>
+        <p:spPr>
+          <a:xfrm>
+            <a:off x="7223760" y="1773936"/>
+            <a:ext cx="4087368" cy="292608"/>
+          </a:xfrm>
+          <a:prstGeom prst="rect">
+            <a:avLst/>
+          </a:prstGeom>
+          <a:noFill/>
+          <a:ln/>
+        </p:spPr>
+        <p:txBody>
+          <a:bodyPr wrap="square" lIns="0" tIns="0" rIns="0" bIns="0" rtlCol="0" anchor="ctr"/>
+          <a:lstStyle/>
+          <a:p>
+            <a:pPr marL="0" indent="0">
+              <a:buNone/>
+            </a:pPr>
+            <a:r>
+              <a:rPr lang="en-US" sz="1650" b="1" dirty="0">
+                <a:solidFill>
+                  <a:srgbClr val="26282C"/>
+                </a:solidFill>
+                <a:latin typeface="Arial" pitchFamily="34" charset="0"/>
+                <a:ea typeface="Arial" pitchFamily="34" charset="-122"/>
+                <a:cs typeface="Arial" pitchFamily="34" charset="-120"/>
+              </a:rPr>
+              <a:t>Code</a:t>
+            </a:r>
+            <a:endParaRPr lang="en-US" sz="1650" dirty="0"/>
+          </a:p>
+        </p:txBody>
+      </p:sp>
+      <p:sp>
+        <p:nvSpPr>
+          <p:cNvPr id="13" name="Text 9"/>
+          <p:cNvSpPr/>
+          <p:nvPr/>
+        </p:nvSpPr>
+        <p:spPr>
+          <a:xfrm>
+            <a:off x="7223760" y="2139696"/>
+            <a:ext cx="4041648" cy="1005840"/>
+          </a:xfrm>
+          <a:prstGeom prst="rect">
+            <a:avLst/>
+          </a:prstGeom>
+          <a:noFill/>
+          <a:ln/>
+        </p:spPr>
+        <p:txBody>
+          <a:bodyPr wrap="square" lIns="0" tIns="0" rIns="0" bIns="0" rtlCol="0" anchor="t"/>
+          <a:lstStyle/>
+          <a:p>
+            <a:pPr marL="0" indent="0">
+              <a:lnSpc>
+                <a:spcPct val="115000"/>
+              </a:lnSpc>
+              <a:buNone/>
+            </a:pPr>
+            <a:r>
+              <a:rPr lang="en-US" sz="1225" dirty="0">
+                <a:solidFill>
+                  <a:srgbClr val="63686E"/>
+                </a:solidFill>
+                <a:latin typeface="Arial" pitchFamily="34" charset="0"/>
+                <a:ea typeface="Arial" pitchFamily="34" charset="-122"/>
+                <a:cs typeface="Arial" pitchFamily="34" charset="-120"/>
+              </a:rPr>
+              <a:t>Two independently sampled implementations must agree on observed behavior — disagreement triggers a third and a vote.</a:t>
+            </a:r>
+            <a:endParaRPr lang="en-US" sz="1225" dirty="0"/>
+          </a:p>
+        </p:txBody>
+      </p:sp>
+      <p:sp>
+        <p:nvSpPr>
+          <p:cNvPr id="14" name="Shape 10"/>
+          <p:cNvSpPr/>
+          <p:nvPr/>
+        </p:nvSpPr>
+        <p:spPr>
+          <a:xfrm>
+            <a:off x="822960" y="3584448"/>
+            <a:ext cx="5230368" cy="1828800"/>
+          </a:xfrm>
+          <a:prstGeom prst="roundRect">
+            <a:avLst>
+              <a:gd name="adj" fmla="val 5000"/>
+            </a:avLst>
+          </a:prstGeom>
+          <a:solidFill>
+            <a:srgbClr val="F6F7F8"/>
+          </a:solidFill>
+          <a:ln/>
+        </p:spPr>
+      </p:sp>
+      <p:sp>
+        <p:nvSpPr>
+          <p:cNvPr id="15" name="Shape 11"/>
+          <p:cNvSpPr/>
+          <p:nvPr/>
+        </p:nvSpPr>
+        <p:spPr>
+          <a:xfrm>
+            <a:off x="1078992" y="3840480"/>
+            <a:ext cx="457200" cy="457200"/>
+          </a:xfrm>
+          <a:prstGeom prst="ellipse">
+            <a:avLst/>
+          </a:prstGeom>
+          <a:solidFill>
+            <a:srgbClr val="FDEBEC"/>
+          </a:solidFill>
+          <a:ln/>
+        </p:spPr>
+      </p:sp>
+      <p:pic>
+        <p:nvPicPr>
+          <p:cNvPr id="16" name="Image 2" descr="preencoded.png"/>
+          <p:cNvPicPr>
+            <a:picLocks noChangeAspect="1"/>
+          </p:cNvPicPr>
+          <p:nvPr/>
+        </p:nvPicPr>
+        <p:blipFill>
+          <a:blip r:embed="rId5"/>
+          <a:stretch>
+            <a:fillRect/>
+          </a:stretch>
+        </p:blipFill>
+        <p:spPr>
+          <a:xfrm>
+            <a:off x="1188720" y="3950208"/>
+            <a:ext cx="237744" cy="237744"/>
+          </a:xfrm>
+          <a:prstGeom prst="rect">
+            <a:avLst/>
+          </a:prstGeom>
+        </p:spPr>
+      </p:pic>
+      <p:sp>
+        <p:nvSpPr>
+          <p:cNvPr id="17" name="Text 12"/>
+          <p:cNvSpPr/>
+          <p:nvPr/>
+        </p:nvSpPr>
+        <p:spPr>
+          <a:xfrm>
+            <a:off x="1719072" y="3877056"/>
+            <a:ext cx="4087368" cy="292608"/>
+          </a:xfrm>
+          <a:prstGeom prst="rect">
+            <a:avLst/>
+          </a:prstGeom>
+          <a:noFill/>
+          <a:ln/>
+        </p:spPr>
+        <p:txBody>
+          <a:bodyPr wrap="square" lIns="0" tIns="0" rIns="0" bIns="0" rtlCol="0" anchor="ctr"/>
+          <a:lstStyle/>
+          <a:p>
+            <a:pPr marL="0" indent="0">
+              <a:buNone/>
+            </a:pPr>
+            <a:r>
+              <a:rPr lang="en-US" sz="1650" b="1" dirty="0">
+                <a:solidFill>
+                  <a:srgbClr val="26282C"/>
+                </a:solidFill>
+                <a:latin typeface="Arial" pitchFamily="34" charset="0"/>
+                <a:ea typeface="Arial" pitchFamily="34" charset="-122"/>
+                <a:cs typeface="Arial" pitchFamily="34" charset="-120"/>
+              </a:rPr>
+              <a:t>Logic</a:t>
+            </a:r>
+            <a:endParaRPr lang="en-US" sz="1650" dirty="0"/>
+          </a:p>
+        </p:txBody>
+      </p:sp>
+      <p:sp>
+        <p:nvSpPr>
+          <p:cNvPr id="18" name="Text 13"/>
+          <p:cNvSpPr/>
+          <p:nvPr/>
+        </p:nvSpPr>
+        <p:spPr>
+          <a:xfrm>
+            <a:off x="1719072" y="4242816"/>
+            <a:ext cx="4041648" cy="1005840"/>
+          </a:xfrm>
+          <a:prstGeom prst="rect">
+            <a:avLst/>
+          </a:prstGeom>
+          <a:noFill/>
+          <a:ln/>
+        </p:spPr>
+        <p:txBody>
+          <a:bodyPr wrap="square" lIns="0" tIns="0" rIns="0" bIns="0" rtlCol="0" anchor="t"/>
+          <a:lstStyle/>
+          <a:p>
+            <a:pPr marL="0" indent="0">
+              <a:lnSpc>
+                <a:spcPct val="115000"/>
+              </a:lnSpc>
+              <a:buNone/>
+            </a:pPr>
+            <a:r>
+              <a:rPr lang="en-US" sz="1225" dirty="0">
+                <a:solidFill>
+                  <a:srgbClr val="63686E"/>
+                </a:solidFill>
+                <a:latin typeface="Arial" pitchFamily="34" charset="0"/>
+                <a:ea typeface="Arial" pitchFamily="34" charset="-122"/>
+                <a:cs typeface="Arial" pitchFamily="34" charset="-120"/>
+              </a:rPr>
+              <a:t>Entities and constraints extracted to JSON, every assignment brute-forced — an answer ships only with a proven unique solution.</a:t>
+            </a:r>
+            <a:endParaRPr lang="en-US" sz="1225" dirty="0"/>
+          </a:p>
+        </p:txBody>
+      </p:sp>
+      <p:sp>
+        <p:nvSpPr>
+          <p:cNvPr id="19" name="Shape 14"/>
+          <p:cNvSpPr/>
+          <p:nvPr/>
+        </p:nvSpPr>
+        <p:spPr>
+          <a:xfrm>
+            <a:off x="6327648" y="3584448"/>
+            <a:ext cx="5230368" cy="1828800"/>
+          </a:xfrm>
+          <a:prstGeom prst="roundRect">
+            <a:avLst>
+              <a:gd name="adj" fmla="val 5000"/>
+            </a:avLst>
+          </a:prstGeom>
+          <a:solidFill>
+            <a:srgbClr val="F6F7F8"/>
+          </a:solidFill>
+          <a:ln/>
+        </p:spPr>
+      </p:sp>
+      <p:sp>
+        <p:nvSpPr>
+          <p:cNvPr id="20" name="Shape 15"/>
+          <p:cNvSpPr/>
+          <p:nvPr/>
+        </p:nvSpPr>
+        <p:spPr>
+          <a:xfrm>
+            <a:off x="6583680" y="3840480"/>
+            <a:ext cx="457200" cy="457200"/>
+          </a:xfrm>
+          <a:prstGeom prst="ellipse">
+            <a:avLst/>
+          </a:prstGeom>
+          <a:solidFill>
+            <a:srgbClr val="FDEBEC"/>
+          </a:solidFill>
+          <a:ln/>
+        </p:spPr>
+      </p:sp>
+      <p:pic>
+        <p:nvPicPr>
+          <p:cNvPr id="21" name="Image 3" descr="preencoded.png"/>
+          <p:cNvPicPr>
+            <a:picLocks noChangeAspect="1"/>
+          </p:cNvPicPr>
+          <p:nvPr/>
+        </p:nvPicPr>
+        <p:blipFill>
+          <a:blip r:embed="rId6"/>
+          <a:stretch>
+            <a:fillRect/>
+          </a:stretch>
+        </p:blipFill>
+        <p:spPr>
+          <a:xfrm>
             <a:off x="6693408" y="3950208"/>
             <a:ext cx="237744" cy="237744"/>
           </a:xfrm>
@@ -5710,7 +5475,7 @@
           <a:bodyPr wrap="square" lIns="0" tIns="0" rIns="0" bIns="0" rtlCol="0" anchor="ctr"/>
           <a:lstStyle/>
           <a:p>
-            <a:pPr indent="0" marL="0">
+            <a:pPr marL="0" indent="0">
               <a:buNone/>
             </a:pPr>
             <a:r>
@@ -5749,7 +5514,7 @@
           <a:bodyPr wrap="square" lIns="0" tIns="0" rIns="0" bIns="0" rtlCol="0" anchor="t"/>
           <a:lstStyle/>
           <a:p>
-            <a:pPr indent="0" marL="0">
+            <a:pPr marL="0" indent="0">
               <a:lnSpc>
                 <a:spcPct val="115000"/>
               </a:lnSpc>
@@ -5813,7 +5578,7 @@
           <a:bodyPr wrap="square" lIns="0" tIns="0" rIns="0" bIns="0" rtlCol="0" anchor="ctr"/>
           <a:lstStyle/>
           <a:p>
-            <a:pPr algn="ctr" indent="0" marL="0">
+            <a:pPr marL="0" indent="0" algn="ctr">
               <a:buNone/>
             </a:pPr>
             <a:r>
@@ -5898,7 +5663,7 @@
           <a:bodyPr wrap="square" lIns="0" tIns="0" rIns="0" bIns="0" rtlCol="0" anchor="ctr"/>
           <a:lstStyle/>
           <a:p>
-            <a:pPr algn="ctr" indent="0" marL="0">
+            <a:pPr marL="0" indent="0" algn="ctr">
               <a:buNone/>
             </a:pPr>
             <a:r>
@@ -5983,7 +5748,7 @@
           <a:bodyPr wrap="square" lIns="0" tIns="0" rIns="0" bIns="0" rtlCol="0" anchor="ctr"/>
           <a:lstStyle/>
           <a:p>
-            <a:pPr algn="ctr" indent="0" marL="0">
+            <a:pPr marL="0" indent="0" algn="ctr">
               <a:buNone/>
             </a:pPr>
             <a:r>
@@ -6017,6 +5782,7 @@
         <a:solidFill>
           <a:srgbClr val="FFFFFF"/>
         </a:solidFill>
+        <a:effectLst/>
       </p:bgPr>
     </p:bg>
     <p:spTree>
@@ -6054,7 +5820,7 @@
           <a:bodyPr wrap="square" lIns="0" tIns="0" rIns="0" bIns="0" rtlCol="0" anchor="ctr"/>
           <a:lstStyle/>
           <a:p>
-            <a:pPr indent="0" marL="0">
+            <a:pPr marL="0" indent="0">
               <a:buNone/>
             </a:pPr>
             <a:r>
@@ -6094,257 +5860,7 @@
       </p:sp>
       <p:pic>
         <p:nvPicPr>
-          <p:cNvPr id="4" name="Image 0" descr="preencoded.png">    </p:cNvPr>
-          <p:cNvPicPr>
-            <a:picLocks noChangeAspect="1"/>
-          </p:cNvPicPr>
-          <p:nvPr/>
-        </p:nvPicPr>
-        <p:blipFill>
-          <a:blip r:embed="rId1"/>
-          <a:stretch>
-            <a:fillRect/>
-          </a:stretch>
-        </p:blipFill>
-        <p:spPr>
-          <a:xfrm>
-            <a:off x="950244" y="1745772"/>
-            <a:ext cx="275783" cy="275783"/>
-          </a:xfrm>
-          <a:prstGeom prst="rect">
-            <a:avLst/>
-          </a:prstGeom>
-        </p:spPr>
-      </p:pic>
-      <p:sp>
-        <p:nvSpPr>
-          <p:cNvPr id="5" name="Text 2"/>
-          <p:cNvSpPr/>
-          <p:nvPr/>
-        </p:nvSpPr>
-        <p:spPr>
-          <a:xfrm>
-            <a:off x="1600200" y="1600200"/>
-            <a:ext cx="5120640" cy="292608"/>
-          </a:xfrm>
-          <a:prstGeom prst="rect">
-            <a:avLst/>
-          </a:prstGeom>
-          <a:noFill/>
-          <a:ln/>
-        </p:spPr>
-        <p:txBody>
-          <a:bodyPr wrap="square" lIns="0" tIns="0" rIns="0" bIns="0" rtlCol="0" anchor="ctr"/>
-          <a:lstStyle/>
-          <a:p>
-            <a:pPr indent="0" marL="0">
-              <a:buNone/>
-            </a:pPr>
-            <a:r>
-              <a:rPr lang="en-US" sz="1650" b="1" dirty="0">
-                <a:solidFill>
-                  <a:srgbClr val="26282C"/>
-                </a:solidFill>
-                <a:latin typeface="Arial" pitchFamily="34" charset="0"/>
-                <a:ea typeface="Arial" pitchFamily="34" charset="-122"/>
-                <a:cs typeface="Arial" pitchFamily="34" charset="-120"/>
-              </a:rPr>
-              <a:t>Weakest answers, cheapest models first</a:t>
-            </a:r>
-            <a:endParaRPr lang="en-US" sz="1650" dirty="0"/>
-          </a:p>
-        </p:txBody>
-      </p:sp>
-      <p:sp>
-        <p:nvSpPr>
-          <p:cNvPr id="6" name="Text 3"/>
-          <p:cNvSpPr/>
-          <p:nvPr/>
-        </p:nvSpPr>
-        <p:spPr>
-          <a:xfrm>
-            <a:off x="1600200" y="1929384"/>
-            <a:ext cx="5120640" cy="777240"/>
-          </a:xfrm>
-          <a:prstGeom prst="rect">
-            <a:avLst/>
-          </a:prstGeom>
-          <a:noFill/>
-          <a:ln/>
-        </p:spPr>
-        <p:txBody>
-          <a:bodyPr wrap="square" lIns="0" tIns="0" rIns="0" bIns="0" rtlCol="0" anchor="t"/>
-          <a:lstStyle/>
-          <a:p>
-            <a:pPr indent="0" marL="0">
-              <a:lnSpc>
-                <a:spcPct val="112000"/>
-              </a:lnSpc>
-              <a:buNone/>
-            </a:pPr>
-            <a:r>
-              <a:rPr lang="en-US" sz="1300" dirty="0">
-                <a:solidFill>
-                  <a:srgbClr val="63686E"/>
-                </a:solidFill>
-                <a:latin typeface="Arial" pitchFamily="34" charset="0"/>
-                <a:ea typeface="Arial" pitchFamily="34" charset="-122"/>
-                <a:cs typeface="Arial" pitchFamily="34" charset="-120"/>
-              </a:rPr>
-              <a:t>Below-threshold answers escalate sequentially, cheapest-estimated-first, with reasoning_effort: low and tight output caps.</a:t>
-            </a:r>
-            <a:endParaRPr lang="en-US" sz="1300" dirty="0"/>
-          </a:p>
-        </p:txBody>
-      </p:sp>
-      <p:sp>
-        <p:nvSpPr>
-          <p:cNvPr id="7" name="Shape 4"/>
-          <p:cNvSpPr/>
-          <p:nvPr/>
-        </p:nvSpPr>
-        <p:spPr>
-          <a:xfrm>
-            <a:off x="822960" y="3035808"/>
-            <a:ext cx="530352" cy="530352"/>
-          </a:xfrm>
-          <a:prstGeom prst="ellipse">
-            <a:avLst/>
-          </a:prstGeom>
-          <a:solidFill>
-            <a:srgbClr val="FDEBEC"/>
-          </a:solidFill>
-          <a:ln/>
-        </p:spPr>
-      </p:sp>
-      <p:pic>
-        <p:nvPicPr>
-          <p:cNvPr id="8" name="Image 1" descr="preencoded.png">    </p:cNvPr>
-          <p:cNvPicPr>
-            <a:picLocks noChangeAspect="1"/>
-          </p:cNvPicPr>
-          <p:nvPr/>
-        </p:nvPicPr>
-        <p:blipFill>
-          <a:blip r:embed="rId2"/>
-          <a:stretch>
-            <a:fillRect/>
-          </a:stretch>
-        </p:blipFill>
-        <p:spPr>
-          <a:xfrm>
-            <a:off x="950244" y="3163092"/>
-            <a:ext cx="275783" cy="275783"/>
-          </a:xfrm>
-          <a:prstGeom prst="rect">
-            <a:avLst/>
-          </a:prstGeom>
-        </p:spPr>
-      </p:pic>
-      <p:sp>
-        <p:nvSpPr>
-          <p:cNvPr id="9" name="Text 5"/>
-          <p:cNvSpPr/>
-          <p:nvPr/>
-        </p:nvSpPr>
-        <p:spPr>
-          <a:xfrm>
-            <a:off x="1600200" y="3017520"/>
-            <a:ext cx="5120640" cy="292608"/>
-          </a:xfrm>
-          <a:prstGeom prst="rect">
-            <a:avLst/>
-          </a:prstGeom>
-          <a:noFill/>
-          <a:ln/>
-        </p:spPr>
-        <p:txBody>
-          <a:bodyPr wrap="square" lIns="0" tIns="0" rIns="0" bIns="0" rtlCol="0" anchor="ctr"/>
-          <a:lstStyle/>
-          <a:p>
-            <a:pPr indent="0" marL="0">
-              <a:buNone/>
-            </a:pPr>
-            <a:r>
-              <a:rPr lang="en-US" sz="1650" b="1" dirty="0">
-                <a:solidFill>
-                  <a:srgbClr val="26282C"/>
-                </a:solidFill>
-                <a:latin typeface="Arial" pitchFamily="34" charset="0"/>
-                <a:ea typeface="Arial" pitchFamily="34" charset="-122"/>
-                <a:cs typeface="Arial" pitchFamily="34" charset="-120"/>
-              </a:rPr>
-              <a:t>Live-measured most frugal model</a:t>
-            </a:r>
-            <a:endParaRPr lang="en-US" sz="1650" dirty="0"/>
-          </a:p>
-        </p:txBody>
-      </p:sp>
-      <p:sp>
-        <p:nvSpPr>
-          <p:cNvPr id="10" name="Text 6"/>
-          <p:cNvSpPr/>
-          <p:nvPr/>
-        </p:nvSpPr>
-        <p:spPr>
-          <a:xfrm>
-            <a:off x="1600200" y="3346704"/>
-            <a:ext cx="5120640" cy="777240"/>
-          </a:xfrm>
-          <a:prstGeom prst="rect">
-            <a:avLst/>
-          </a:prstGeom>
-          <a:noFill/>
-          <a:ln/>
-        </p:spPr>
-        <p:txBody>
-          <a:bodyPr wrap="square" lIns="0" tIns="0" rIns="0" bIns="0" rtlCol="0" anchor="t"/>
-          <a:lstStyle/>
-          <a:p>
-            <a:pPr indent="0" marL="0">
-              <a:lnSpc>
-                <a:spcPct val="112000"/>
-              </a:lnSpc>
-              <a:buNone/>
-            </a:pPr>
-            <a:r>
-              <a:rPr lang="en-US" sz="1300" dirty="0">
-                <a:solidFill>
-                  <a:srgbClr val="63686E"/>
-                </a:solidFill>
-                <a:latin typeface="Arial" pitchFamily="34" charset="0"/>
-                <a:ea typeface="Arial" pitchFamily="34" charset="-122"/>
-                <a:cs typeface="Arial" pitchFamily="34" charset="-120"/>
-              </a:rPr>
-              <a:t>We benchmarked every serverless model: gpt-oss-120b at low reasoning effort — 137 tokens for a complete word problem.</a:t>
-            </a:r>
-            <a:endParaRPr lang="en-US" sz="1300" dirty="0"/>
-          </a:p>
-        </p:txBody>
-      </p:sp>
-      <p:sp>
-        <p:nvSpPr>
-          <p:cNvPr id="11" name="Shape 7"/>
-          <p:cNvSpPr/>
-          <p:nvPr/>
-        </p:nvSpPr>
-        <p:spPr>
-          <a:xfrm>
-            <a:off x="822960" y="4453128"/>
-            <a:ext cx="530352" cy="530352"/>
-          </a:xfrm>
-          <a:prstGeom prst="ellipse">
-            <a:avLst/>
-          </a:prstGeom>
-          <a:solidFill>
-            <a:srgbClr val="FDEBEC"/>
-          </a:solidFill>
-          <a:ln/>
-        </p:spPr>
-      </p:sp>
-      <p:pic>
-        <p:nvPicPr>
-          <p:cNvPr id="12" name="Image 2" descr="preencoded.png">    </p:cNvPr>
+          <p:cNvPr id="4" name="Image 0" descr="preencoded.png"/>
           <p:cNvPicPr>
             <a:picLocks noChangeAspect="1"/>
           </p:cNvPicPr>
@@ -6358,6 +5874,256 @@
         </p:blipFill>
         <p:spPr>
           <a:xfrm>
+            <a:off x="950244" y="1745772"/>
+            <a:ext cx="275783" cy="275783"/>
+          </a:xfrm>
+          <a:prstGeom prst="rect">
+            <a:avLst/>
+          </a:prstGeom>
+        </p:spPr>
+      </p:pic>
+      <p:sp>
+        <p:nvSpPr>
+          <p:cNvPr id="5" name="Text 2"/>
+          <p:cNvSpPr/>
+          <p:nvPr/>
+        </p:nvSpPr>
+        <p:spPr>
+          <a:xfrm>
+            <a:off x="1600200" y="1600200"/>
+            <a:ext cx="5120640" cy="292608"/>
+          </a:xfrm>
+          <a:prstGeom prst="rect">
+            <a:avLst/>
+          </a:prstGeom>
+          <a:noFill/>
+          <a:ln/>
+        </p:spPr>
+        <p:txBody>
+          <a:bodyPr wrap="square" lIns="0" tIns="0" rIns="0" bIns="0" rtlCol="0" anchor="ctr"/>
+          <a:lstStyle/>
+          <a:p>
+            <a:pPr marL="0" indent="0">
+              <a:buNone/>
+            </a:pPr>
+            <a:r>
+              <a:rPr lang="en-US" sz="1650" b="1" dirty="0">
+                <a:solidFill>
+                  <a:srgbClr val="26282C"/>
+                </a:solidFill>
+                <a:latin typeface="Arial" pitchFamily="34" charset="0"/>
+                <a:ea typeface="Arial" pitchFamily="34" charset="-122"/>
+                <a:cs typeface="Arial" pitchFamily="34" charset="-120"/>
+              </a:rPr>
+              <a:t>Weakest answers, cheapest models first</a:t>
+            </a:r>
+            <a:endParaRPr lang="en-US" sz="1650" dirty="0"/>
+          </a:p>
+        </p:txBody>
+      </p:sp>
+      <p:sp>
+        <p:nvSpPr>
+          <p:cNvPr id="6" name="Text 3"/>
+          <p:cNvSpPr/>
+          <p:nvPr/>
+        </p:nvSpPr>
+        <p:spPr>
+          <a:xfrm>
+            <a:off x="1600200" y="1929384"/>
+            <a:ext cx="5120640" cy="777240"/>
+          </a:xfrm>
+          <a:prstGeom prst="rect">
+            <a:avLst/>
+          </a:prstGeom>
+          <a:noFill/>
+          <a:ln/>
+        </p:spPr>
+        <p:txBody>
+          <a:bodyPr wrap="square" lIns="0" tIns="0" rIns="0" bIns="0" rtlCol="0" anchor="t"/>
+          <a:lstStyle/>
+          <a:p>
+            <a:pPr marL="0" indent="0">
+              <a:lnSpc>
+                <a:spcPct val="112000"/>
+              </a:lnSpc>
+              <a:buNone/>
+            </a:pPr>
+            <a:r>
+              <a:rPr lang="en-US" sz="1300" dirty="0">
+                <a:solidFill>
+                  <a:srgbClr val="63686E"/>
+                </a:solidFill>
+                <a:latin typeface="Arial" pitchFamily="34" charset="0"/>
+                <a:ea typeface="Arial" pitchFamily="34" charset="-122"/>
+                <a:cs typeface="Arial" pitchFamily="34" charset="-120"/>
+              </a:rPr>
+              <a:t>Below-threshold answers escalate sequentially, cheapest-estimated-first, with reasoning_effort: low and tight output caps.</a:t>
+            </a:r>
+            <a:endParaRPr lang="en-US" sz="1300" dirty="0"/>
+          </a:p>
+        </p:txBody>
+      </p:sp>
+      <p:sp>
+        <p:nvSpPr>
+          <p:cNvPr id="7" name="Shape 4"/>
+          <p:cNvSpPr/>
+          <p:nvPr/>
+        </p:nvSpPr>
+        <p:spPr>
+          <a:xfrm>
+            <a:off x="822960" y="3035808"/>
+            <a:ext cx="530352" cy="530352"/>
+          </a:xfrm>
+          <a:prstGeom prst="ellipse">
+            <a:avLst/>
+          </a:prstGeom>
+          <a:solidFill>
+            <a:srgbClr val="FDEBEC"/>
+          </a:solidFill>
+          <a:ln/>
+        </p:spPr>
+      </p:sp>
+      <p:pic>
+        <p:nvPicPr>
+          <p:cNvPr id="8" name="Image 1" descr="preencoded.png"/>
+          <p:cNvPicPr>
+            <a:picLocks noChangeAspect="1"/>
+          </p:cNvPicPr>
+          <p:nvPr/>
+        </p:nvPicPr>
+        <p:blipFill>
+          <a:blip r:embed="rId4"/>
+          <a:stretch>
+            <a:fillRect/>
+          </a:stretch>
+        </p:blipFill>
+        <p:spPr>
+          <a:xfrm>
+            <a:off x="950244" y="3163092"/>
+            <a:ext cx="275783" cy="275783"/>
+          </a:xfrm>
+          <a:prstGeom prst="rect">
+            <a:avLst/>
+          </a:prstGeom>
+        </p:spPr>
+      </p:pic>
+      <p:sp>
+        <p:nvSpPr>
+          <p:cNvPr id="9" name="Text 5"/>
+          <p:cNvSpPr/>
+          <p:nvPr/>
+        </p:nvSpPr>
+        <p:spPr>
+          <a:xfrm>
+            <a:off x="1600200" y="3017520"/>
+            <a:ext cx="5120640" cy="292608"/>
+          </a:xfrm>
+          <a:prstGeom prst="rect">
+            <a:avLst/>
+          </a:prstGeom>
+          <a:noFill/>
+          <a:ln/>
+        </p:spPr>
+        <p:txBody>
+          <a:bodyPr wrap="square" lIns="0" tIns="0" rIns="0" bIns="0" rtlCol="0" anchor="ctr"/>
+          <a:lstStyle/>
+          <a:p>
+            <a:pPr marL="0" indent="0">
+              <a:buNone/>
+            </a:pPr>
+            <a:r>
+              <a:rPr lang="en-US" sz="1650" b="1" dirty="0">
+                <a:solidFill>
+                  <a:srgbClr val="26282C"/>
+                </a:solidFill>
+                <a:latin typeface="Arial" pitchFamily="34" charset="0"/>
+                <a:ea typeface="Arial" pitchFamily="34" charset="-122"/>
+                <a:cs typeface="Arial" pitchFamily="34" charset="-120"/>
+              </a:rPr>
+              <a:t>Live-measured most frugal model</a:t>
+            </a:r>
+            <a:endParaRPr lang="en-US" sz="1650" dirty="0"/>
+          </a:p>
+        </p:txBody>
+      </p:sp>
+      <p:sp>
+        <p:nvSpPr>
+          <p:cNvPr id="10" name="Text 6"/>
+          <p:cNvSpPr/>
+          <p:nvPr/>
+        </p:nvSpPr>
+        <p:spPr>
+          <a:xfrm>
+            <a:off x="1600200" y="3346704"/>
+            <a:ext cx="5120640" cy="777240"/>
+          </a:xfrm>
+          <a:prstGeom prst="rect">
+            <a:avLst/>
+          </a:prstGeom>
+          <a:noFill/>
+          <a:ln/>
+        </p:spPr>
+        <p:txBody>
+          <a:bodyPr wrap="square" lIns="0" tIns="0" rIns="0" bIns="0" rtlCol="0" anchor="t"/>
+          <a:lstStyle/>
+          <a:p>
+            <a:pPr marL="0" indent="0">
+              <a:lnSpc>
+                <a:spcPct val="112000"/>
+              </a:lnSpc>
+              <a:buNone/>
+            </a:pPr>
+            <a:r>
+              <a:rPr lang="en-US" sz="1300" dirty="0">
+                <a:solidFill>
+                  <a:srgbClr val="63686E"/>
+                </a:solidFill>
+                <a:latin typeface="Arial" pitchFamily="34" charset="0"/>
+                <a:ea typeface="Arial" pitchFamily="34" charset="-122"/>
+                <a:cs typeface="Arial" pitchFamily="34" charset="-120"/>
+              </a:rPr>
+              <a:t>We benchmarked every serverless model: gpt-oss-120b at low reasoning effort — 137 tokens for a complete word problem.</a:t>
+            </a:r>
+            <a:endParaRPr lang="en-US" sz="1300" dirty="0"/>
+          </a:p>
+        </p:txBody>
+      </p:sp>
+      <p:sp>
+        <p:nvSpPr>
+          <p:cNvPr id="11" name="Shape 7"/>
+          <p:cNvSpPr/>
+          <p:nvPr/>
+        </p:nvSpPr>
+        <p:spPr>
+          <a:xfrm>
+            <a:off x="822960" y="4453128"/>
+            <a:ext cx="530352" cy="530352"/>
+          </a:xfrm>
+          <a:prstGeom prst="ellipse">
+            <a:avLst/>
+          </a:prstGeom>
+          <a:solidFill>
+            <a:srgbClr val="FDEBEC"/>
+          </a:solidFill>
+          <a:ln/>
+        </p:spPr>
+      </p:sp>
+      <p:pic>
+        <p:nvPicPr>
+          <p:cNvPr id="12" name="Image 2" descr="preencoded.png"/>
+          <p:cNvPicPr>
+            <a:picLocks noChangeAspect="1"/>
+          </p:cNvPicPr>
+          <p:nvPr/>
+        </p:nvPicPr>
+        <p:blipFill>
+          <a:blip r:embed="rId5"/>
+          <a:stretch>
+            <a:fillRect/>
+          </a:stretch>
+        </p:blipFill>
+        <p:spPr>
+          <a:xfrm>
             <a:off x="950244" y="4580412"/>
             <a:ext cx="275783" cy="275783"/>
           </a:xfrm>
@@ -6387,7 +6153,7 @@
           <a:bodyPr wrap="square" lIns="0" tIns="0" rIns="0" bIns="0" rtlCol="0" anchor="ctr"/>
           <a:lstStyle/>
           <a:p>
-            <a:pPr indent="0" marL="0">
+            <a:pPr marL="0" indent="0">
               <a:buNone/>
             </a:pPr>
             <a:r>
@@ -6426,7 +6192,7 @@
           <a:bodyPr wrap="square" lIns="0" tIns="0" rIns="0" bIns="0" rtlCol="0" anchor="t"/>
           <a:lstStyle/>
           <a:p>
-            <a:pPr indent="0" marL="0">
+            <a:pPr marL="0" indent="0">
               <a:lnSpc>
                 <a:spcPct val="112000"/>
               </a:lnSpc>
@@ -6468,7 +6234,7 @@
           </a:solidFill>
           <a:ln/>
           <a:effectLst>
-            <a:outerShdw sx="100000" sy="100000" kx="0" ky="0" algn="bl" rotWithShape="0" blurRad="88900" dist="25400" dir="5400000">
+            <a:outerShdw blurRad="88900" dist="25400" dir="5400000" algn="bl" rotWithShape="0">
               <a:srgbClr val="9AA0A6">
                 <a:alpha val="30000"/>
               </a:srgbClr>
@@ -6497,11 +6263,11 @@
           <a:bodyPr wrap="square" lIns="0" tIns="0" rIns="0" bIns="0" rtlCol="0" anchor="ctr"/>
           <a:lstStyle/>
           <a:p>
-            <a:pPr indent="0" marL="0">
-              <a:buNone/>
-            </a:pPr>
-            <a:r>
-              <a:rPr lang="en-US" sz="1200" b="1" spc="300" kern="0" dirty="0">
+            <a:pPr marL="0" indent="0">
+              <a:buNone/>
+            </a:pPr>
+            <a:r>
+              <a:rPr lang="en-US" sz="1200" b="1" kern="0" spc="300" dirty="0">
                 <a:solidFill>
                   <a:srgbClr val="63686E"/>
                 </a:solidFill>
@@ -6536,7 +6302,7 @@
           <a:bodyPr wrap="square" lIns="0" tIns="0" rIns="0" bIns="0" rtlCol="0" anchor="ctr"/>
           <a:lstStyle/>
           <a:p>
-            <a:pPr indent="0" marL="0">
+            <a:pPr marL="0" indent="0">
               <a:buNone/>
             </a:pPr>
             <a:r>
@@ -6550,9 +6316,6 @@
               </a:rPr>
               <a:t>900</a:t>
             </a:r>
-            <a:pPr indent="0" marL="0">
-              <a:buNone/>
-            </a:pPr>
             <a:r>
               <a:rPr lang="en-US" sz="1600" dirty="0">
                 <a:solidFill>
@@ -6589,7 +6352,7 @@
           <a:bodyPr wrap="square" lIns="0" tIns="0" rIns="0" bIns="0" rtlCol="0" anchor="ctr"/>
           <a:lstStyle/>
           <a:p>
-            <a:pPr indent="0" marL="0">
+            <a:pPr marL="0" indent="0">
               <a:buNone/>
             </a:pPr>
             <a:r>
@@ -6672,7 +6435,7 @@
           <a:bodyPr wrap="square" lIns="0" tIns="0" rIns="0" bIns="0" rtlCol="0" anchor="ctr"/>
           <a:lstStyle/>
           <a:p>
-            <a:pPr indent="0" marL="0">
+            <a:pPr marL="0" indent="0">
               <a:buNone/>
             </a:pPr>
             <a:r>
@@ -6734,7 +6497,7 @@
           <a:bodyPr wrap="square" lIns="0" tIns="0" rIns="0" bIns="0" rtlCol="0" anchor="ctr"/>
           <a:lstStyle/>
           <a:p>
-            <a:pPr indent="0" marL="0">
+            <a:pPr marL="0" indent="0">
               <a:lnSpc>
                 <a:spcPct val="125000"/>
               </a:lnSpc>
@@ -6751,16 +6514,10 @@
               </a:rPr>
               <a:t>ESCALATION_BUDGET_TOKENS = 0</a:t>
             </a:r>
-            <a:pPr indent="0" marL="0">
-              <a:lnSpc>
-                <a:spcPct val="125000"/>
-              </a:lnSpc>
-              <a:buNone/>
-            </a:pPr>
             <a:endParaRPr lang="en-US" sz="1150" dirty="0"/>
           </a:p>
           <a:p>
-            <a:pPr indent="0" marL="0">
+            <a:pPr marL="0" indent="0">
               <a:lnSpc>
                 <a:spcPct val="125000"/>
               </a:lnSpc>
@@ -6797,6 +6554,7 @@
         <a:solidFill>
           <a:srgbClr val="FFFFFF"/>
         </a:solidFill>
+        <a:effectLst/>
       </p:bgPr>
     </p:bg>
     <p:spTree>
@@ -6834,7 +6592,7 @@
           <a:bodyPr wrap="square" lIns="0" tIns="0" rIns="0" bIns="0" rtlCol="0" anchor="ctr"/>
           <a:lstStyle/>
           <a:p>
-            <a:pPr indent="0" marL="0">
+            <a:pPr marL="0" indent="0">
               <a:buNone/>
             </a:pPr>
             <a:r>
@@ -6944,7 +6702,7 @@
           <a:bodyPr wrap="square" lIns="0" tIns="0" rIns="0" bIns="0" rtlCol="0" anchor="ctr"/>
           <a:lstStyle/>
           <a:p>
-            <a:pPr algn="l" indent="0" marL="0">
+            <a:pPr marL="0" indent="0" algn="l">
               <a:lnSpc>
                 <a:spcPct val="105000"/>
               </a:lnSpc>
@@ -6962,12 +6720,6 @@
               <a:t>0:00
 </a:t>
             </a:r>
-            <a:pPr algn="l" indent="0" marL="0">
-              <a:lnSpc>
-                <a:spcPct val="105000"/>
-              </a:lnSpc>
-              <a:buNone/>
-            </a:pPr>
             <a:r>
               <a:rPr lang="en-US" sz="1000" dirty="0">
                 <a:solidFill>
@@ -7029,7 +6781,7 @@
           <a:bodyPr wrap="square" lIns="0" tIns="0" rIns="0" bIns="0" rtlCol="0" anchor="ctr"/>
           <a:lstStyle/>
           <a:p>
-            <a:pPr algn="ctr" indent="0" marL="0">
+            <a:pPr marL="0" indent="0" algn="ctr">
               <a:lnSpc>
                 <a:spcPct val="105000"/>
               </a:lnSpc>
@@ -7047,12 +6799,6 @@
               <a:t>3:52
 </a:t>
             </a:r>
-            <a:pPr algn="ctr" indent="0" marL="0">
-              <a:lnSpc>
-                <a:spcPct val="105000"/>
-              </a:lnSpc>
-              <a:buNone/>
-            </a:pPr>
             <a:r>
               <a:rPr lang="en-US" sz="1000" dirty="0">
                 <a:solidFill>
@@ -7114,7 +6860,7 @@
           <a:bodyPr wrap="square" lIns="0" tIns="0" rIns="0" bIns="0" rtlCol="0" anchor="ctr"/>
           <a:lstStyle/>
           <a:p>
-            <a:pPr algn="ctr" indent="0" marL="0">
+            <a:pPr marL="0" indent="0" algn="ctr">
               <a:lnSpc>
                 <a:spcPct val="105000"/>
               </a:lnSpc>
@@ -7132,12 +6878,6 @@
               <a:t>7:25
 </a:t>
             </a:r>
-            <a:pPr algn="ctr" indent="0" marL="0">
-              <a:lnSpc>
-                <a:spcPct val="105000"/>
-              </a:lnSpc>
-              <a:buNone/>
-            </a:pPr>
             <a:r>
               <a:rPr lang="en-US" sz="1000" dirty="0">
                 <a:solidFill>
@@ -7199,7 +6939,7 @@
           <a:bodyPr wrap="square" lIns="0" tIns="0" rIns="0" bIns="0" rtlCol="0" anchor="ctr"/>
           <a:lstStyle/>
           <a:p>
-            <a:pPr algn="ctr" indent="0" marL="0">
+            <a:pPr marL="0" indent="0" algn="ctr">
               <a:lnSpc>
                 <a:spcPct val="105000"/>
               </a:lnSpc>
@@ -7217,12 +6957,6 @@
               <a:t>8:25
 </a:t>
             </a:r>
-            <a:pPr algn="ctr" indent="0" marL="0">
-              <a:lnSpc>
-                <a:spcPct val="105000"/>
-              </a:lnSpc>
-              <a:buNone/>
-            </a:pPr>
             <a:r>
               <a:rPr lang="en-US" sz="1000" dirty="0">
                 <a:solidFill>
@@ -7284,7 +7018,7 @@
           <a:bodyPr wrap="square" lIns="0" tIns="0" rIns="0" bIns="0" rtlCol="0" anchor="ctr"/>
           <a:lstStyle/>
           <a:p>
-            <a:pPr algn="ctr" indent="0" marL="0">
+            <a:pPr marL="0" indent="0" algn="ctr">
               <a:lnSpc>
                 <a:spcPct val="105000"/>
               </a:lnSpc>
@@ -7302,12 +7036,6 @@
               <a:t>8:55
 </a:t>
             </a:r>
-            <a:pPr algn="ctr" indent="0" marL="0">
-              <a:lnSpc>
-                <a:spcPct val="105000"/>
-              </a:lnSpc>
-              <a:buNone/>
-            </a:pPr>
             <a:r>
               <a:rPr lang="en-US" sz="1000" dirty="0">
                 <a:solidFill>
@@ -7369,7 +7097,7 @@
           <a:bodyPr wrap="square" lIns="0" tIns="0" rIns="0" bIns="0" rtlCol="0" anchor="ctr"/>
           <a:lstStyle/>
           <a:p>
-            <a:pPr algn="r" indent="0" marL="0">
+            <a:pPr marL="0" indent="0" algn="r">
               <a:lnSpc>
                 <a:spcPct val="105000"/>
               </a:lnSpc>
@@ -7387,12 +7115,6 @@
               <a:t>10:00
 </a:t>
             </a:r>
-            <a:pPr algn="r" indent="0" marL="0">
-              <a:lnSpc>
-                <a:spcPct val="105000"/>
-              </a:lnSpc>
-              <a:buNone/>
-            </a:pPr>
             <a:r>
               <a:rPr lang="en-US" sz="1000" dirty="0">
                 <a:solidFill>
@@ -7452,301 +7174,7 @@
       </p:sp>
       <p:pic>
         <p:nvPicPr>
-          <p:cNvPr id="19" name="Image 0" descr="preencoded.png">    </p:cNvPr>
-          <p:cNvPicPr>
-            <a:picLocks noChangeAspect="1"/>
-          </p:cNvPicPr>
-          <p:nvPr/>
-        </p:nvPicPr>
-        <p:blipFill>
-          <a:blip r:embed="rId1"/>
-          <a:stretch>
-            <a:fillRect/>
-          </a:stretch>
-        </p:blipFill>
-        <p:spPr>
-          <a:xfrm>
-            <a:off x="1161654" y="4453494"/>
-            <a:ext cx="218724" cy="218724"/>
-          </a:xfrm>
-          <a:prstGeom prst="rect">
-            <a:avLst/>
-          </a:prstGeom>
-        </p:spPr>
-      </p:pic>
-      <p:sp>
-        <p:nvSpPr>
-          <p:cNvPr id="20" name="Text 17"/>
-          <p:cNvSpPr/>
-          <p:nvPr/>
-        </p:nvSpPr>
-        <p:spPr>
-          <a:xfrm>
-            <a:off x="1627632" y="4398264"/>
-            <a:ext cx="2322576" cy="274320"/>
-          </a:xfrm>
-          <a:prstGeom prst="rect">
-            <a:avLst/>
-          </a:prstGeom>
-          <a:noFill/>
-          <a:ln/>
-        </p:spPr>
-        <p:txBody>
-          <a:bodyPr wrap="square" lIns="0" tIns="0" rIns="0" bIns="0" rtlCol="0" anchor="ctr"/>
-          <a:lstStyle/>
-          <a:p>
-            <a:pPr indent="0" marL="0">
-              <a:buNone/>
-            </a:pPr>
-            <a:r>
-              <a:rPr lang="en-US" sz="1450" b="1" dirty="0">
-                <a:solidFill>
-                  <a:srgbClr val="26282C"/>
-                </a:solidFill>
-                <a:latin typeface="Arial" pitchFamily="34" charset="0"/>
-                <a:ea typeface="Arial" pitchFamily="34" charset="-122"/>
-                <a:cs typeface="Arial" pitchFamily="34" charset="-120"/>
-              </a:rPr>
-              <a:t>Speed governor</a:t>
-            </a:r>
-            <a:endParaRPr lang="en-US" sz="1450" dirty="0"/>
-          </a:p>
-        </p:txBody>
-      </p:sp>
-      <p:sp>
-        <p:nvSpPr>
-          <p:cNvPr id="21" name="Text 18"/>
-          <p:cNvSpPr/>
-          <p:nvPr/>
-        </p:nvSpPr>
-        <p:spPr>
-          <a:xfrm>
-            <a:off x="1060704" y="4892040"/>
-            <a:ext cx="2852928" cy="960120"/>
-          </a:xfrm>
-          <a:prstGeom prst="rect">
-            <a:avLst/>
-          </a:prstGeom>
-          <a:noFill/>
-          <a:ln/>
-        </p:spPr>
-        <p:txBody>
-          <a:bodyPr wrap="square" lIns="0" tIns="0" rIns="0" bIns="0" rtlCol="0" anchor="t"/>
-          <a:lstStyle/>
-          <a:p>
-            <a:pPr indent="0" marL="0">
-              <a:lnSpc>
-                <a:spcPct val="115000"/>
-              </a:lnSpc>
-              <a:buNone/>
-            </a:pPr>
-            <a:r>
-              <a:rPr lang="en-US" sz="1150" dirty="0">
-                <a:solidFill>
-                  <a:srgbClr val="63686E"/>
-                </a:solidFill>
-                <a:latin typeface="Arial" pitchFamily="34" charset="0"/>
-                <a:ea typeface="Arial" pitchFamily="34" charset="-122"/>
-                <a:cs typeface="Arial" pitchFamily="34" charset="-120"/>
-              </a:rPr>
-              <a:t>A startup probe measures real tok/s and sets sampling depth: full → lean → panic. Slow CPUs degrade gracefully, never fatally.</a:t>
-            </a:r>
-            <a:endParaRPr lang="en-US" sz="1150" dirty="0"/>
-          </a:p>
-        </p:txBody>
-      </p:sp>
-      <p:sp>
-        <p:nvSpPr>
-          <p:cNvPr id="22" name="Shape 19"/>
-          <p:cNvSpPr/>
-          <p:nvPr/>
-        </p:nvSpPr>
-        <p:spPr>
-          <a:xfrm>
-            <a:off x="4425696" y="4114800"/>
-            <a:ext cx="3328416" cy="1874520"/>
-          </a:xfrm>
-          <a:prstGeom prst="roundRect">
-            <a:avLst>
-              <a:gd name="adj" fmla="val 4878"/>
-            </a:avLst>
-          </a:prstGeom>
-          <a:solidFill>
-            <a:srgbClr val="F6F7F8"/>
-          </a:solidFill>
-          <a:ln/>
-        </p:spPr>
-      </p:sp>
-      <p:sp>
-        <p:nvSpPr>
-          <p:cNvPr id="23" name="Shape 20"/>
-          <p:cNvSpPr/>
-          <p:nvPr/>
-        </p:nvSpPr>
-        <p:spPr>
-          <a:xfrm>
-            <a:off x="4663440" y="4352544"/>
-            <a:ext cx="420624" cy="420624"/>
-          </a:xfrm>
-          <a:prstGeom prst="ellipse">
-            <a:avLst/>
-          </a:prstGeom>
-          <a:solidFill>
-            <a:srgbClr val="FDEBEC"/>
-          </a:solidFill>
-          <a:ln/>
-        </p:spPr>
-      </p:sp>
-      <p:pic>
-        <p:nvPicPr>
-          <p:cNvPr id="24" name="Image 1" descr="preencoded.png">    </p:cNvPr>
-          <p:cNvPicPr>
-            <a:picLocks noChangeAspect="1"/>
-          </p:cNvPicPr>
-          <p:nvPr/>
-        </p:nvPicPr>
-        <p:blipFill>
-          <a:blip r:embed="rId2"/>
-          <a:stretch>
-            <a:fillRect/>
-          </a:stretch>
-        </p:blipFill>
-        <p:spPr>
-          <a:xfrm>
-            <a:off x="4764390" y="4453494"/>
-            <a:ext cx="218724" cy="218724"/>
-          </a:xfrm>
-          <a:prstGeom prst="rect">
-            <a:avLst/>
-          </a:prstGeom>
-        </p:spPr>
-      </p:pic>
-      <p:sp>
-        <p:nvSpPr>
-          <p:cNvPr id="25" name="Text 21"/>
-          <p:cNvSpPr/>
-          <p:nvPr/>
-        </p:nvSpPr>
-        <p:spPr>
-          <a:xfrm>
-            <a:off x="5230368" y="4398264"/>
-            <a:ext cx="2322576" cy="274320"/>
-          </a:xfrm>
-          <a:prstGeom prst="rect">
-            <a:avLst/>
-          </a:prstGeom>
-          <a:noFill/>
-          <a:ln/>
-        </p:spPr>
-        <p:txBody>
-          <a:bodyPr wrap="square" lIns="0" tIns="0" rIns="0" bIns="0" rtlCol="0" anchor="ctr"/>
-          <a:lstStyle/>
-          <a:p>
-            <a:pPr indent="0" marL="0">
-              <a:buNone/>
-            </a:pPr>
-            <a:r>
-              <a:rPr lang="en-US" sz="1450" b="1" dirty="0">
-                <a:solidFill>
-                  <a:srgbClr val="26282C"/>
-                </a:solidFill>
-                <a:latin typeface="Arial" pitchFamily="34" charset="0"/>
-                <a:ea typeface="Arial" pitchFamily="34" charset="-122"/>
-                <a:cs typeface="Arial" pitchFamily="34" charset="-120"/>
-              </a:rPr>
-              <a:t>Atomic output</a:t>
-            </a:r>
-            <a:endParaRPr lang="en-US" sz="1450" dirty="0"/>
-          </a:p>
-        </p:txBody>
-      </p:sp>
-      <p:sp>
-        <p:nvSpPr>
-          <p:cNvPr id="26" name="Text 22"/>
-          <p:cNvSpPr/>
-          <p:nvPr/>
-        </p:nvSpPr>
-        <p:spPr>
-          <a:xfrm>
-            <a:off x="4663440" y="4892040"/>
-            <a:ext cx="2852928" cy="960120"/>
-          </a:xfrm>
-          <a:prstGeom prst="rect">
-            <a:avLst/>
-          </a:prstGeom>
-          <a:noFill/>
-          <a:ln/>
-        </p:spPr>
-        <p:txBody>
-          <a:bodyPr wrap="square" lIns="0" tIns="0" rIns="0" bIns="0" rtlCol="0" anchor="t"/>
-          <a:lstStyle/>
-          <a:p>
-            <a:pPr indent="0" marL="0">
-              <a:lnSpc>
-                <a:spcPct val="115000"/>
-              </a:lnSpc>
-              <a:buNone/>
-            </a:pPr>
-            <a:r>
-              <a:rPr lang="en-US" sz="1150" dirty="0">
-                <a:solidFill>
-                  <a:srgbClr val="63686E"/>
-                </a:solidFill>
-                <a:latin typeface="Arial" pitchFamily="34" charset="0"/>
-                <a:ea typeface="Arial" pitchFamily="34" charset="-122"/>
-                <a:cs typeface="Arial" pitchFamily="34" charset="-120"/>
-              </a:rPr>
-              <a:t>results.json is valid JSON after every single task, and each task runs in its own exception boundary.</a:t>
-            </a:r>
-            <a:endParaRPr lang="en-US" sz="1150" dirty="0"/>
-          </a:p>
-        </p:txBody>
-      </p:sp>
-      <p:sp>
-        <p:nvSpPr>
-          <p:cNvPr id="27" name="Shape 23"/>
-          <p:cNvSpPr/>
-          <p:nvPr/>
-        </p:nvSpPr>
-        <p:spPr>
-          <a:xfrm>
-            <a:off x="8028432" y="4114800"/>
-            <a:ext cx="3328416" cy="1874520"/>
-          </a:xfrm>
-          <a:prstGeom prst="roundRect">
-            <a:avLst>
-              <a:gd name="adj" fmla="val 4878"/>
-            </a:avLst>
-          </a:prstGeom>
-          <a:solidFill>
-            <a:srgbClr val="F6F7F8"/>
-          </a:solidFill>
-          <a:ln/>
-        </p:spPr>
-      </p:sp>
-      <p:sp>
-        <p:nvSpPr>
-          <p:cNvPr id="28" name="Shape 24"/>
-          <p:cNvSpPr/>
-          <p:nvPr/>
-        </p:nvSpPr>
-        <p:spPr>
-          <a:xfrm>
-            <a:off x="8266176" y="4352544"/>
-            <a:ext cx="420624" cy="420624"/>
-          </a:xfrm>
-          <a:prstGeom prst="ellipse">
-            <a:avLst/>
-          </a:prstGeom>
-          <a:solidFill>
-            <a:srgbClr val="FDEBEC"/>
-          </a:solidFill>
-          <a:ln/>
-        </p:spPr>
-      </p:sp>
-      <p:pic>
-        <p:nvPicPr>
-          <p:cNvPr id="29" name="Image 2" descr="preencoded.png">    </p:cNvPr>
+          <p:cNvPr id="19" name="Image 0" descr="preencoded.png"/>
           <p:cNvPicPr>
             <a:picLocks noChangeAspect="1"/>
           </p:cNvPicPr>
@@ -7760,6 +7188,300 @@
         </p:blipFill>
         <p:spPr>
           <a:xfrm>
+            <a:off x="1161654" y="4453494"/>
+            <a:ext cx="218724" cy="218724"/>
+          </a:xfrm>
+          <a:prstGeom prst="rect">
+            <a:avLst/>
+          </a:prstGeom>
+        </p:spPr>
+      </p:pic>
+      <p:sp>
+        <p:nvSpPr>
+          <p:cNvPr id="20" name="Text 17"/>
+          <p:cNvSpPr/>
+          <p:nvPr/>
+        </p:nvSpPr>
+        <p:spPr>
+          <a:xfrm>
+            <a:off x="1627632" y="4398264"/>
+            <a:ext cx="2322576" cy="274320"/>
+          </a:xfrm>
+          <a:prstGeom prst="rect">
+            <a:avLst/>
+          </a:prstGeom>
+          <a:noFill/>
+          <a:ln/>
+        </p:spPr>
+        <p:txBody>
+          <a:bodyPr wrap="square" lIns="0" tIns="0" rIns="0" bIns="0" rtlCol="0" anchor="ctr"/>
+          <a:lstStyle/>
+          <a:p>
+            <a:pPr marL="0" indent="0">
+              <a:buNone/>
+            </a:pPr>
+            <a:r>
+              <a:rPr lang="en-US" sz="1450" b="1" dirty="0">
+                <a:solidFill>
+                  <a:srgbClr val="26282C"/>
+                </a:solidFill>
+                <a:latin typeface="Arial" pitchFamily="34" charset="0"/>
+                <a:ea typeface="Arial" pitchFamily="34" charset="-122"/>
+                <a:cs typeface="Arial" pitchFamily="34" charset="-120"/>
+              </a:rPr>
+              <a:t>Speed governor</a:t>
+            </a:r>
+            <a:endParaRPr lang="en-US" sz="1450" dirty="0"/>
+          </a:p>
+        </p:txBody>
+      </p:sp>
+      <p:sp>
+        <p:nvSpPr>
+          <p:cNvPr id="21" name="Text 18"/>
+          <p:cNvSpPr/>
+          <p:nvPr/>
+        </p:nvSpPr>
+        <p:spPr>
+          <a:xfrm>
+            <a:off x="1060704" y="4892040"/>
+            <a:ext cx="2852928" cy="960120"/>
+          </a:xfrm>
+          <a:prstGeom prst="rect">
+            <a:avLst/>
+          </a:prstGeom>
+          <a:noFill/>
+          <a:ln/>
+        </p:spPr>
+        <p:txBody>
+          <a:bodyPr wrap="square" lIns="0" tIns="0" rIns="0" bIns="0" rtlCol="0" anchor="t"/>
+          <a:lstStyle/>
+          <a:p>
+            <a:pPr marL="0" indent="0">
+              <a:lnSpc>
+                <a:spcPct val="115000"/>
+              </a:lnSpc>
+              <a:buNone/>
+            </a:pPr>
+            <a:r>
+              <a:rPr lang="en-US" sz="1150" dirty="0">
+                <a:solidFill>
+                  <a:srgbClr val="63686E"/>
+                </a:solidFill>
+                <a:latin typeface="Arial" pitchFamily="34" charset="0"/>
+                <a:ea typeface="Arial" pitchFamily="34" charset="-122"/>
+                <a:cs typeface="Arial" pitchFamily="34" charset="-120"/>
+              </a:rPr>
+              <a:t>A startup probe measures real tok/s and sets sampling depth: full → lean → panic. Slow CPUs degrade gracefully, never fatally.</a:t>
+            </a:r>
+            <a:endParaRPr lang="en-US" sz="1150" dirty="0"/>
+          </a:p>
+        </p:txBody>
+      </p:sp>
+      <p:sp>
+        <p:nvSpPr>
+          <p:cNvPr id="22" name="Shape 19"/>
+          <p:cNvSpPr/>
+          <p:nvPr/>
+        </p:nvSpPr>
+        <p:spPr>
+          <a:xfrm>
+            <a:off x="4425696" y="4114800"/>
+            <a:ext cx="3328416" cy="1874520"/>
+          </a:xfrm>
+          <a:prstGeom prst="roundRect">
+            <a:avLst>
+              <a:gd name="adj" fmla="val 4878"/>
+            </a:avLst>
+          </a:prstGeom>
+          <a:solidFill>
+            <a:srgbClr val="F6F7F8"/>
+          </a:solidFill>
+          <a:ln/>
+        </p:spPr>
+      </p:sp>
+      <p:sp>
+        <p:nvSpPr>
+          <p:cNvPr id="23" name="Shape 20"/>
+          <p:cNvSpPr/>
+          <p:nvPr/>
+        </p:nvSpPr>
+        <p:spPr>
+          <a:xfrm>
+            <a:off x="4663440" y="4352544"/>
+            <a:ext cx="420624" cy="420624"/>
+          </a:xfrm>
+          <a:prstGeom prst="ellipse">
+            <a:avLst/>
+          </a:prstGeom>
+          <a:solidFill>
+            <a:srgbClr val="FDEBEC"/>
+          </a:solidFill>
+          <a:ln/>
+        </p:spPr>
+      </p:sp>
+      <p:pic>
+        <p:nvPicPr>
+          <p:cNvPr id="24" name="Image 1" descr="preencoded.png"/>
+          <p:cNvPicPr>
+            <a:picLocks noChangeAspect="1"/>
+          </p:cNvPicPr>
+          <p:nvPr/>
+        </p:nvPicPr>
+        <p:blipFill>
+          <a:blip r:embed="rId4"/>
+          <a:stretch>
+            <a:fillRect/>
+          </a:stretch>
+        </p:blipFill>
+        <p:spPr>
+          <a:xfrm>
+            <a:off x="4764390" y="4453494"/>
+            <a:ext cx="218724" cy="218724"/>
+          </a:xfrm>
+          <a:prstGeom prst="rect">
+            <a:avLst/>
+          </a:prstGeom>
+        </p:spPr>
+      </p:pic>
+      <p:sp>
+        <p:nvSpPr>
+          <p:cNvPr id="25" name="Text 21"/>
+          <p:cNvSpPr/>
+          <p:nvPr/>
+        </p:nvSpPr>
+        <p:spPr>
+          <a:xfrm>
+            <a:off x="5230368" y="4398264"/>
+            <a:ext cx="2322576" cy="274320"/>
+          </a:xfrm>
+          <a:prstGeom prst="rect">
+            <a:avLst/>
+          </a:prstGeom>
+          <a:noFill/>
+          <a:ln/>
+        </p:spPr>
+        <p:txBody>
+          <a:bodyPr wrap="square" lIns="0" tIns="0" rIns="0" bIns="0" rtlCol="0" anchor="ctr"/>
+          <a:lstStyle/>
+          <a:p>
+            <a:pPr marL="0" indent="0">
+              <a:buNone/>
+            </a:pPr>
+            <a:r>
+              <a:rPr lang="en-US" sz="1450" b="1" dirty="0">
+                <a:solidFill>
+                  <a:srgbClr val="26282C"/>
+                </a:solidFill>
+                <a:latin typeface="Arial" pitchFamily="34" charset="0"/>
+                <a:ea typeface="Arial" pitchFamily="34" charset="-122"/>
+                <a:cs typeface="Arial" pitchFamily="34" charset="-120"/>
+              </a:rPr>
+              <a:t>Atomic output</a:t>
+            </a:r>
+            <a:endParaRPr lang="en-US" sz="1450" dirty="0"/>
+          </a:p>
+        </p:txBody>
+      </p:sp>
+      <p:sp>
+        <p:nvSpPr>
+          <p:cNvPr id="26" name="Text 22"/>
+          <p:cNvSpPr/>
+          <p:nvPr/>
+        </p:nvSpPr>
+        <p:spPr>
+          <a:xfrm>
+            <a:off x="4663440" y="4892040"/>
+            <a:ext cx="2852928" cy="960120"/>
+          </a:xfrm>
+          <a:prstGeom prst="rect">
+            <a:avLst/>
+          </a:prstGeom>
+          <a:noFill/>
+          <a:ln/>
+        </p:spPr>
+        <p:txBody>
+          <a:bodyPr wrap="square" lIns="0" tIns="0" rIns="0" bIns="0" rtlCol="0" anchor="t"/>
+          <a:lstStyle/>
+          <a:p>
+            <a:pPr marL="0" indent="0">
+              <a:lnSpc>
+                <a:spcPct val="115000"/>
+              </a:lnSpc>
+              <a:buNone/>
+            </a:pPr>
+            <a:r>
+              <a:rPr lang="en-US" sz="1150" dirty="0">
+                <a:solidFill>
+                  <a:srgbClr val="63686E"/>
+                </a:solidFill>
+                <a:latin typeface="Arial" pitchFamily="34" charset="0"/>
+                <a:ea typeface="Arial" pitchFamily="34" charset="-122"/>
+                <a:cs typeface="Arial" pitchFamily="34" charset="-120"/>
+              </a:rPr>
+              <a:t>results.json is valid JSON after every single task, and each task runs in its own exception boundary.</a:t>
+            </a:r>
+            <a:endParaRPr lang="en-US" sz="1150" dirty="0"/>
+          </a:p>
+        </p:txBody>
+      </p:sp>
+      <p:sp>
+        <p:nvSpPr>
+          <p:cNvPr id="27" name="Shape 23"/>
+          <p:cNvSpPr/>
+          <p:nvPr/>
+        </p:nvSpPr>
+        <p:spPr>
+          <a:xfrm>
+            <a:off x="8028432" y="4114800"/>
+            <a:ext cx="3328416" cy="1874520"/>
+          </a:xfrm>
+          <a:prstGeom prst="roundRect">
+            <a:avLst>
+              <a:gd name="adj" fmla="val 4878"/>
+            </a:avLst>
+          </a:prstGeom>
+          <a:solidFill>
+            <a:srgbClr val="F6F7F8"/>
+          </a:solidFill>
+          <a:ln/>
+        </p:spPr>
+      </p:sp>
+      <p:sp>
+        <p:nvSpPr>
+          <p:cNvPr id="28" name="Shape 24"/>
+          <p:cNvSpPr/>
+          <p:nvPr/>
+        </p:nvSpPr>
+        <p:spPr>
+          <a:xfrm>
+            <a:off x="8266176" y="4352544"/>
+            <a:ext cx="420624" cy="420624"/>
+          </a:xfrm>
+          <a:prstGeom prst="ellipse">
+            <a:avLst/>
+          </a:prstGeom>
+          <a:solidFill>
+            <a:srgbClr val="FDEBEC"/>
+          </a:solidFill>
+          <a:ln/>
+        </p:spPr>
+      </p:sp>
+      <p:pic>
+        <p:nvPicPr>
+          <p:cNvPr id="29" name="Image 2" descr="preencoded.png"/>
+          <p:cNvPicPr>
+            <a:picLocks noChangeAspect="1"/>
+          </p:cNvPicPr>
+          <p:nvPr/>
+        </p:nvPicPr>
+        <p:blipFill>
+          <a:blip r:embed="rId5"/>
+          <a:stretch>
+            <a:fillRect/>
+          </a:stretch>
+        </p:blipFill>
+        <p:spPr>
+          <a:xfrm>
             <a:off x="8367126" y="4453494"/>
             <a:ext cx="218724" cy="218724"/>
           </a:xfrm>
@@ -7789,7 +7511,7 @@
           <a:bodyPr wrap="square" lIns="0" tIns="0" rIns="0" bIns="0" rtlCol="0" anchor="ctr"/>
           <a:lstStyle/>
           <a:p>
-            <a:pPr indent="0" marL="0">
+            <a:pPr marL="0" indent="0">
               <a:buNone/>
             </a:pPr>
             <a:r>
@@ -7828,7 +7550,7 @@
           <a:bodyPr wrap="square" lIns="0" tIns="0" rIns="0" bIns="0" rtlCol="0" anchor="t"/>
           <a:lstStyle/>
           <a:p>
-            <a:pPr indent="0" marL="0">
+            <a:pPr marL="0" indent="0">
               <a:lnSpc>
                 <a:spcPct val="115000"/>
               </a:lnSpc>
@@ -7865,6 +7587,7 @@
         <a:solidFill>
           <a:srgbClr val="FFFFFF"/>
         </a:solidFill>
+        <a:effectLst/>
       </p:bgPr>
     </p:bg>
     <p:spTree>
@@ -7902,7 +7625,7 @@
           <a:bodyPr wrap="square" lIns="0" tIns="0" rIns="0" bIns="0" rtlCol="0" anchor="ctr"/>
           <a:lstStyle/>
           <a:p>
-            <a:pPr indent="0" marL="0">
+            <a:pPr marL="0" indent="0">
               <a:buNone/>
             </a:pPr>
             <a:r>
@@ -7941,7 +7664,7 @@
           <a:bodyPr wrap="square" lIns="0" tIns="0" rIns="0" bIns="0" rtlCol="0" anchor="ctr"/>
           <a:lstStyle/>
           <a:p>
-            <a:pPr indent="0" marL="0">
+            <a:pPr marL="0" indent="0">
               <a:buNone/>
             </a:pPr>
             <a:r>
@@ -7985,7 +7708,7 @@
             <a:prstDash val="solid"/>
           </a:ln>
           <a:effectLst>
-            <a:outerShdw sx="100000" sy="100000" kx="0" ky="0" algn="bl" rotWithShape="0" blurRad="88900" dist="25400" dir="5400000">
+            <a:outerShdw blurRad="88900" dist="25400" dir="5400000" algn="bl" rotWithShape="0">
               <a:srgbClr val="9AA0A6">
                 <a:alpha val="30000"/>
               </a:srgbClr>
@@ -8014,7 +7737,7 @@
           <a:bodyPr wrap="square" lIns="0" tIns="0" rIns="0" bIns="0" rtlCol="0" anchor="ctr"/>
           <a:lstStyle/>
           <a:p>
-            <a:pPr indent="0" marL="0">
+            <a:pPr marL="0" indent="0">
               <a:buNone/>
             </a:pPr>
             <a:r>
@@ -8053,7 +7776,7 @@
           <a:bodyPr wrap="square" lIns="0" tIns="0" rIns="0" bIns="0" rtlCol="0" anchor="ctr"/>
           <a:lstStyle/>
           <a:p>
-            <a:pPr indent="0" marL="0">
+            <a:pPr marL="0" indent="0">
               <a:lnSpc>
                 <a:spcPct val="110000"/>
               </a:lnSpc>
@@ -8073,7 +7796,7 @@
             <a:endParaRPr lang="en-US" sz="1150" dirty="0"/>
           </a:p>
           <a:p>
-            <a:pPr indent="0" marL="0">
+            <a:pPr marL="0" indent="0">
               <a:lnSpc>
                 <a:spcPct val="110000"/>
               </a:lnSpc>
@@ -8115,7 +7838,7 @@
           </a:solidFill>
           <a:ln/>
           <a:effectLst>
-            <a:outerShdw sx="100000" sy="100000" kx="0" ky="0" algn="bl" rotWithShape="0" blurRad="88900" dist="25400" dir="5400000">
+            <a:outerShdw blurRad="88900" dist="25400" dir="5400000" algn="bl" rotWithShape="0">
               <a:srgbClr val="9AA0A6">
                 <a:alpha val="30000"/>
               </a:srgbClr>
@@ -8144,7 +7867,7 @@
           <a:bodyPr wrap="square" lIns="0" tIns="0" rIns="0" bIns="0" rtlCol="0" anchor="ctr"/>
           <a:lstStyle/>
           <a:p>
-            <a:pPr indent="0" marL="0">
+            <a:pPr marL="0" indent="0">
               <a:buNone/>
             </a:pPr>
             <a:r>
@@ -8183,7 +7906,7 @@
           <a:bodyPr wrap="square" lIns="0" tIns="0" rIns="0" bIns="0" rtlCol="0" anchor="ctr"/>
           <a:lstStyle/>
           <a:p>
-            <a:pPr indent="0" marL="0">
+            <a:pPr marL="0" indent="0">
               <a:lnSpc>
                 <a:spcPct val="110000"/>
               </a:lnSpc>
@@ -8203,7 +7926,7 @@
             <a:endParaRPr lang="en-US" sz="1150" dirty="0"/>
           </a:p>
           <a:p>
-            <a:pPr indent="0" marL="0">
+            <a:pPr marL="0" indent="0">
               <a:lnSpc>
                 <a:spcPct val="110000"/>
               </a:lnSpc>
@@ -8250,7 +7973,7 @@
             <a:prstDash val="solid"/>
           </a:ln>
           <a:effectLst>
-            <a:outerShdw sx="100000" sy="100000" kx="0" ky="0" algn="bl" rotWithShape="0" blurRad="88900" dist="25400" dir="5400000">
+            <a:outerShdw blurRad="88900" dist="25400" dir="5400000" algn="bl" rotWithShape="0">
               <a:srgbClr val="9AA0A6">
                 <a:alpha val="30000"/>
               </a:srgbClr>
@@ -8279,7 +8002,7 @@
           <a:bodyPr wrap="square" lIns="0" tIns="0" rIns="0" bIns="0" rtlCol="0" anchor="ctr"/>
           <a:lstStyle/>
           <a:p>
-            <a:pPr indent="0" marL="0">
+            <a:pPr marL="0" indent="0">
               <a:buNone/>
             </a:pPr>
             <a:r>
@@ -8318,7 +8041,7 @@
           <a:bodyPr wrap="square" lIns="0" tIns="0" rIns="0" bIns="0" rtlCol="0" anchor="ctr"/>
           <a:lstStyle/>
           <a:p>
-            <a:pPr indent="0" marL="0">
+            <a:pPr marL="0" indent="0">
               <a:lnSpc>
                 <a:spcPct val="110000"/>
               </a:lnSpc>
@@ -8338,7 +8061,7 @@
             <a:endParaRPr lang="en-US" sz="1150" dirty="0"/>
           </a:p>
           <a:p>
-            <a:pPr indent="0" marL="0">
+            <a:pPr marL="0" indent="0">
               <a:lnSpc>
                 <a:spcPct val="110000"/>
               </a:lnSpc>
@@ -8385,7 +8108,7 @@
             <a:prstDash val="solid"/>
           </a:ln>
           <a:effectLst>
-            <a:outerShdw sx="100000" sy="100000" kx="0" ky="0" algn="bl" rotWithShape="0" blurRad="88900" dist="25400" dir="5400000">
+            <a:outerShdw blurRad="88900" dist="25400" dir="5400000" algn="bl" rotWithShape="0">
               <a:srgbClr val="9AA0A6">
                 <a:alpha val="30000"/>
               </a:srgbClr>
@@ -8414,7 +8137,7 @@
           <a:bodyPr wrap="square" lIns="0" tIns="0" rIns="0" bIns="0" rtlCol="0" anchor="ctr"/>
           <a:lstStyle/>
           <a:p>
-            <a:pPr indent="0" marL="0">
+            <a:pPr marL="0" indent="0">
               <a:buNone/>
             </a:pPr>
             <a:r>
@@ -8453,7 +8176,7 @@
           <a:bodyPr wrap="square" lIns="0" tIns="0" rIns="0" bIns="0" rtlCol="0" anchor="ctr"/>
           <a:lstStyle/>
           <a:p>
-            <a:pPr indent="0" marL="0">
+            <a:pPr marL="0" indent="0">
               <a:lnSpc>
                 <a:spcPct val="110000"/>
               </a:lnSpc>
@@ -8473,7 +8196,7 @@
             <a:endParaRPr lang="en-US" sz="1150" dirty="0"/>
           </a:p>
           <a:p>
-            <a:pPr indent="0" marL="0">
+            <a:pPr marL="0" indent="0">
               <a:lnSpc>
                 <a:spcPct val="110000"/>
               </a:lnSpc>
@@ -8537,7 +8260,7 @@
           <a:bodyPr wrap="square" lIns="0" tIns="0" rIns="0" bIns="0" rtlCol="0" anchor="ctr"/>
           <a:lstStyle/>
           <a:p>
-            <a:pPr algn="ctr" indent="0" marL="0">
+            <a:pPr marL="0" indent="0" algn="ctr">
               <a:buNone/>
             </a:pPr>
             <a:r>
@@ -8598,7 +8321,7 @@
           <a:bodyPr wrap="square" lIns="0" tIns="0" rIns="0" bIns="0" rtlCol="0" anchor="ctr"/>
           <a:lstStyle/>
           <a:p>
-            <a:pPr algn="ctr" indent="0" marL="0">
+            <a:pPr marL="0" indent="0" algn="ctr">
               <a:buNone/>
             </a:pPr>
             <a:r>
@@ -8659,7 +8382,7 @@
           <a:bodyPr wrap="square" lIns="0" tIns="0" rIns="0" bIns="0" rtlCol="0" anchor="ctr"/>
           <a:lstStyle/>
           <a:p>
-            <a:pPr algn="ctr" indent="0" marL="0">
+            <a:pPr marL="0" indent="0" algn="ctr">
               <a:buNone/>
             </a:pPr>
             <a:r>
@@ -8720,7 +8443,7 @@
           <a:bodyPr wrap="square" lIns="0" tIns="0" rIns="0" bIns="0" rtlCol="0" anchor="ctr"/>
           <a:lstStyle/>
           <a:p>
-            <a:pPr algn="ctr" indent="0" marL="0">
+            <a:pPr marL="0" indent="0" algn="ctr">
               <a:buNone/>
             </a:pPr>
             <a:r>
@@ -8781,7 +8504,7 @@
           <a:bodyPr wrap="square" lIns="0" tIns="0" rIns="0" bIns="0" rtlCol="0" anchor="ctr"/>
           <a:lstStyle/>
           <a:p>
-            <a:pPr algn="ctr" indent="0" marL="0">
+            <a:pPr marL="0" indent="0" algn="ctr">
               <a:buNone/>
             </a:pPr>
             <a:r>
@@ -8842,7 +8565,7 @@
           <a:bodyPr wrap="square" lIns="0" tIns="0" rIns="0" bIns="0" rtlCol="0" anchor="ctr"/>
           <a:lstStyle/>
           <a:p>
-            <a:pPr algn="ctr" indent="0" marL="0">
+            <a:pPr marL="0" indent="0" algn="ctr">
               <a:buNone/>
             </a:pPr>
             <a:r>
@@ -8881,7 +8604,7 @@
           <a:bodyPr wrap="square" lIns="0" tIns="0" rIns="0" bIns="0" rtlCol="0" anchor="ctr"/>
           <a:lstStyle/>
           <a:p>
-            <a:pPr indent="0" marL="0">
+            <a:pPr marL="0" indent="0">
               <a:buNone/>
             </a:pPr>
             <a:r>
@@ -8943,7 +8666,7 @@
           <a:bodyPr wrap="square" lIns="0" tIns="0" rIns="0" bIns="0" rtlCol="0" anchor="ctr"/>
           <a:lstStyle/>
           <a:p>
-            <a:pPr indent="0" marL="0">
+            <a:pPr marL="0" indent="0">
               <a:buNone/>
             </a:pPr>
             <a:r>
@@ -8957,9 +8680,6 @@
               </a:rPr>
               <a:t>FrugalRouter</a:t>
             </a:r>
-            <a:pPr indent="0" marL="0">
-              <a:buNone/>
-            </a:pPr>
             <a:r>
               <a:rPr lang="en-US" sz="2400" b="1" dirty="0">
                 <a:solidFill>
@@ -9276,4 +8996,319 @@
     </a:ext>
   </a:extLst>
 </a:theme>
+</file>
+
+<file path=ppt/theme/theme2.xml><?xml version="1.0" encoding="utf-8"?>
+<a:theme xmlns:a="http://schemas.openxmlformats.org/drawingml/2006/main" name="Office Theme">
+  <a:themeElements>
+    <a:clrScheme name="Office">
+      <a:dk1>
+        <a:sysClr val="windowText" lastClr="000000"/>
+      </a:dk1>
+      <a:lt1>
+        <a:sysClr val="window" lastClr="FFFFFF"/>
+      </a:lt1>
+      <a:dk2>
+        <a:srgbClr val="0E2841"/>
+      </a:dk2>
+      <a:lt2>
+        <a:srgbClr val="E8E8E8"/>
+      </a:lt2>
+      <a:accent1>
+        <a:srgbClr val="156082"/>
+      </a:accent1>
+      <a:accent2>
+        <a:srgbClr val="E97132"/>
+      </a:accent2>
+      <a:accent3>
+        <a:srgbClr val="196B24"/>
+      </a:accent3>
+      <a:accent4>
+        <a:srgbClr val="0F9ED5"/>
+      </a:accent4>
+      <a:accent5>
+        <a:srgbClr val="A02B93"/>
+      </a:accent5>
+      <a:accent6>
+        <a:srgbClr val="4EA72E"/>
+      </a:accent6>
+      <a:hlink>
+        <a:srgbClr val="467886"/>
+      </a:hlink>
+      <a:folHlink>
+        <a:srgbClr val="96607D"/>
+      </a:folHlink>
+    </a:clrScheme>
+    <a:fontScheme name="Office">
+      <a:majorFont>
+        <a:latin typeface="Aptos Display" panose="02110004020202020204"/>
+        <a:ea typeface=""/>
+        <a:cs typeface=""/>
+        <a:font script="Jpan" typeface="游ゴシック Light"/>
+        <a:font script="Hang" typeface="맑은 고딕"/>
+        <a:font script="Hans" typeface="等线 Light"/>
+        <a:font script="Hant" typeface="新細明體"/>
+        <a:font script="Arab" typeface="Times New Roman"/>
+        <a:font script="Hebr" typeface="Times New Roman"/>
+        <a:font script="Thai" typeface="Angsana New"/>
+        <a:font script="Ethi" typeface="Nyala"/>
+        <a:font script="Beng" typeface="Vrinda"/>
+        <a:font script="Gujr" typeface="Shruti"/>
+        <a:font script="Khmr" typeface="MoolBoran"/>
+        <a:font script="Knda" typeface="Tunga"/>
+        <a:font script="Guru" typeface="Raavi"/>
+        <a:font script="Cans" typeface="Euphemia"/>
+        <a:font script="Cher" typeface="Plantagenet Cherokee"/>
+        <a:font script="Yiii" typeface="Microsoft Yi Baiti"/>
+        <a:font script="Tibt" typeface="Microsoft Himalaya"/>
+        <a:font script="Thaa" typeface="MV Boli"/>
+        <a:font script="Deva" typeface="Mangal"/>
+        <a:font script="Telu" typeface="Gautami"/>
+        <a:font script="Taml" typeface="Latha"/>
+        <a:font script="Syrc" typeface="Estrangelo Edessa"/>
+        <a:font script="Orya" typeface="Kalinga"/>
+        <a:font script="Mlym" typeface="Kartika"/>
+        <a:font script="Laoo" typeface="DokChampa"/>
+        <a:font script="Sinh" typeface="Iskoola Pota"/>
+        <a:font script="Mong" typeface="Mongolian Baiti"/>
+        <a:font script="Viet" typeface="Times New Roman"/>
+        <a:font script="Uigh" typeface="Microsoft Uighur"/>
+        <a:font script="Geor" typeface="Sylfaen"/>
+        <a:font script="Armn" typeface="Arial"/>
+        <a:font script="Bugi" typeface="Leelawadee UI"/>
+        <a:font script="Bopo" typeface="Microsoft JhengHei"/>
+        <a:font script="Java" typeface="Javanese Text"/>
+        <a:font script="Lisu" typeface="Segoe UI"/>
+        <a:font script="Mymr" typeface="Myanmar Text"/>
+        <a:font script="Nkoo" typeface="Ebrima"/>
+        <a:font script="Olck" typeface="Nirmala UI"/>
+        <a:font script="Osma" typeface="Ebrima"/>
+        <a:font script="Phag" typeface="Phagspa"/>
+        <a:font script="Syrn" typeface="Estrangelo Edessa"/>
+        <a:font script="Syrj" typeface="Estrangelo Edessa"/>
+        <a:font script="Syre" typeface="Estrangelo Edessa"/>
+        <a:font script="Sora" typeface="Nirmala UI"/>
+        <a:font script="Tale" typeface="Microsoft Tai Le"/>
+        <a:font script="Talu" typeface="Microsoft New Tai Lue"/>
+        <a:font script="Tfng" typeface="Ebrima"/>
+      </a:majorFont>
+      <a:minorFont>
+        <a:latin typeface="Aptos" panose="02110004020202020204"/>
+        <a:ea typeface=""/>
+        <a:cs typeface=""/>
+        <a:font script="Jpan" typeface="游ゴシック"/>
+        <a:font script="Hang" typeface="맑은 고딕"/>
+        <a:font script="Hans" typeface="等线"/>
+        <a:font script="Hant" typeface="新細明體"/>
+        <a:font script="Arab" typeface="Arial"/>
+        <a:font script="Hebr" typeface="Arial"/>
+        <a:font script="Thai" typeface="Cordia New"/>
+        <a:font script="Ethi" typeface="Nyala"/>
+        <a:font script="Beng" typeface="Vrinda"/>
+        <a:font script="Gujr" typeface="Shruti"/>
+        <a:font script="Khmr" typeface="DaunPenh"/>
+        <a:font script="Knda" typeface="Tunga"/>
+        <a:font script="Guru" typeface="Raavi"/>
+        <a:font script="Cans" typeface="Euphemia"/>
+        <a:font script="Cher" typeface="Plantagenet Cherokee"/>
+        <a:font script="Yiii" typeface="Microsoft Yi Baiti"/>
+        <a:font script="Tibt" typeface="Microsoft Himalaya"/>
+        <a:font script="Thaa" typeface="MV Boli"/>
+        <a:font script="Deva" typeface="Mangal"/>
+        <a:font script="Telu" typeface="Gautami"/>
+        <a:font script="Taml" typeface="Latha"/>
+        <a:font script="Syrc" typeface="Estrangelo Edessa"/>
+        <a:font script="Orya" typeface="Kalinga"/>
+        <a:font script="Mlym" typeface="Kartika"/>
+        <a:font script="Laoo" typeface="DokChampa"/>
+        <a:font script="Sinh" typeface="Iskoola Pota"/>
+        <a:font script="Mong" typeface="Mongolian Baiti"/>
+        <a:font script="Viet" typeface="Arial"/>
+        <a:font script="Uigh" typeface="Microsoft Uighur"/>
+        <a:font script="Geor" typeface="Sylfaen"/>
+        <a:font script="Armn" typeface="Arial"/>
+        <a:font script="Bugi" typeface="Leelawadee UI"/>
+        <a:font script="Bopo" typeface="Microsoft JhengHei"/>
+        <a:font script="Java" typeface="Javanese Text"/>
+        <a:font script="Lisu" typeface="Segoe UI"/>
+        <a:font script="Mymr" typeface="Myanmar Text"/>
+        <a:font script="Nkoo" typeface="Ebrima"/>
+        <a:font script="Olck" typeface="Nirmala UI"/>
+        <a:font script="Osma" typeface="Ebrima"/>
+        <a:font script="Phag" typeface="Phagspa"/>
+        <a:font script="Syrn" typeface="Estrangelo Edessa"/>
+        <a:font script="Syrj" typeface="Estrangelo Edessa"/>
+        <a:font script="Syre" typeface="Estrangelo Edessa"/>
+        <a:font script="Sora" typeface="Nirmala UI"/>
+        <a:font script="Tale" typeface="Microsoft Tai Le"/>
+        <a:font script="Talu" typeface="Microsoft New Tai Lue"/>
+        <a:font script="Tfng" typeface="Ebrima"/>
+      </a:minorFont>
+    </a:fontScheme>
+    <a:fmtScheme name="Office">
+      <a:fillStyleLst>
+        <a:solidFill>
+          <a:schemeClr val="phClr"/>
+        </a:solidFill>
+        <a:gradFill rotWithShape="1">
+          <a:gsLst>
+            <a:gs pos="0">
+              <a:schemeClr val="phClr">
+                <a:lumMod val="110000"/>
+                <a:satMod val="105000"/>
+                <a:tint val="67000"/>
+              </a:schemeClr>
+            </a:gs>
+            <a:gs pos="50000">
+              <a:schemeClr val="phClr">
+                <a:lumMod val="105000"/>
+                <a:satMod val="103000"/>
+                <a:tint val="73000"/>
+              </a:schemeClr>
+            </a:gs>
+            <a:gs pos="100000">
+              <a:schemeClr val="phClr">
+                <a:lumMod val="105000"/>
+                <a:satMod val="109000"/>
+                <a:tint val="81000"/>
+              </a:schemeClr>
+            </a:gs>
+          </a:gsLst>
+          <a:lin ang="5400000" scaled="0"/>
+        </a:gradFill>
+        <a:gradFill rotWithShape="1">
+          <a:gsLst>
+            <a:gs pos="0">
+              <a:schemeClr val="phClr">
+                <a:satMod val="103000"/>
+                <a:lumMod val="102000"/>
+                <a:tint val="94000"/>
+              </a:schemeClr>
+            </a:gs>
+            <a:gs pos="50000">
+              <a:schemeClr val="phClr">
+                <a:satMod val="110000"/>
+                <a:lumMod val="100000"/>
+                <a:shade val="100000"/>
+              </a:schemeClr>
+            </a:gs>
+            <a:gs pos="100000">
+              <a:schemeClr val="phClr">
+                <a:lumMod val="99000"/>
+                <a:satMod val="120000"/>
+                <a:shade val="78000"/>
+              </a:schemeClr>
+            </a:gs>
+          </a:gsLst>
+          <a:lin ang="5400000" scaled="0"/>
+        </a:gradFill>
+      </a:fillStyleLst>
+      <a:lnStyleLst>
+        <a:ln w="12700" cap="flat" cmpd="sng" algn="ctr">
+          <a:solidFill>
+            <a:schemeClr val="phClr"/>
+          </a:solidFill>
+          <a:prstDash val="solid"/>
+          <a:miter lim="800000"/>
+        </a:ln>
+        <a:ln w="19050" cap="flat" cmpd="sng" algn="ctr">
+          <a:solidFill>
+            <a:schemeClr val="phClr"/>
+          </a:solidFill>
+          <a:prstDash val="solid"/>
+          <a:miter lim="800000"/>
+        </a:ln>
+        <a:ln w="25400" cap="flat" cmpd="sng" algn="ctr">
+          <a:solidFill>
+            <a:schemeClr val="phClr"/>
+          </a:solidFill>
+          <a:prstDash val="solid"/>
+          <a:miter lim="800000"/>
+        </a:ln>
+      </a:lnStyleLst>
+      <a:effectStyleLst>
+        <a:effectStyle>
+          <a:effectLst/>
+        </a:effectStyle>
+        <a:effectStyle>
+          <a:effectLst/>
+        </a:effectStyle>
+        <a:effectStyle>
+          <a:effectLst>
+            <a:outerShdw blurRad="57150" dist="19050" dir="5400000" algn="ctr" rotWithShape="0">
+              <a:srgbClr val="000000">
+                <a:alpha val="63000"/>
+              </a:srgbClr>
+            </a:outerShdw>
+          </a:effectLst>
+        </a:effectStyle>
+      </a:effectStyleLst>
+      <a:bgFillStyleLst>
+        <a:solidFill>
+          <a:schemeClr val="phClr"/>
+        </a:solidFill>
+        <a:solidFill>
+          <a:schemeClr val="phClr">
+            <a:tint val="95000"/>
+            <a:satMod val="170000"/>
+          </a:schemeClr>
+        </a:solidFill>
+        <a:gradFill rotWithShape="1">
+          <a:gsLst>
+            <a:gs pos="0">
+              <a:schemeClr val="phClr">
+                <a:tint val="93000"/>
+                <a:satMod val="150000"/>
+                <a:shade val="98000"/>
+                <a:lumMod val="102000"/>
+              </a:schemeClr>
+            </a:gs>
+            <a:gs pos="50000">
+              <a:schemeClr val="phClr">
+                <a:tint val="98000"/>
+                <a:satMod val="130000"/>
+                <a:shade val="90000"/>
+                <a:lumMod val="103000"/>
+              </a:schemeClr>
+            </a:gs>
+            <a:gs pos="100000">
+              <a:schemeClr val="phClr">
+                <a:shade val="63000"/>
+                <a:satMod val="120000"/>
+              </a:schemeClr>
+            </a:gs>
+          </a:gsLst>
+          <a:lin ang="5400000" scaled="0"/>
+        </a:gradFill>
+      </a:bgFillStyleLst>
+    </a:fmtScheme>
+  </a:themeElements>
+  <a:objectDefaults>
+    <a:lnDef>
+      <a:spPr/>
+      <a:bodyPr/>
+      <a:lstStyle/>
+      <a:style>
+        <a:lnRef idx="2">
+          <a:schemeClr val="accent1"/>
+        </a:lnRef>
+        <a:fillRef idx="0">
+          <a:schemeClr val="accent1"/>
+        </a:fillRef>
+        <a:effectRef idx="1">
+          <a:schemeClr val="accent1"/>
+        </a:effectRef>
+        <a:fontRef idx="minor">
+          <a:schemeClr val="tx1"/>
+        </a:fontRef>
+      </a:style>
+    </a:lnDef>
+  </a:objectDefaults>
+  <a:extraClrSchemeLst/>
+  <a:extLst>
+    <a:ext uri="{05A4C25C-085E-4340-85A3-A5531E510DB2}">
+      <thm15:themeFamily xmlns:thm15="http://schemas.microsoft.com/office/thememl/2012/main" name="Office Theme" id="{2E142A2C-CD16-42D6-873A-C26D2A0506FA}" vid="{1BDDFF52-6CD6-40A5-AB3C-68EB2F1E4D0A}"/>
+    </a:ext>
+  </a:extLst>
+</a:theme>
 </file>
</xml_diff>